<commit_message>
finalize project 2 presentation
</commit_message>
<xml_diff>
--- a/projects/slides/nlp-project2-presentation.pptx
+++ b/projects/slides/nlp-project2-presentation.pptx
@@ -7,13 +7,20 @@
   <p:sldIdLst>
     <p:sldId id="256" r:id="rId2"/>
     <p:sldId id="257" r:id="rId3"/>
-    <p:sldId id="258" r:id="rId4"/>
-    <p:sldId id="259" r:id="rId5"/>
-    <p:sldId id="260" r:id="rId6"/>
-    <p:sldId id="261" r:id="rId7"/>
-    <p:sldId id="262" r:id="rId8"/>
-    <p:sldId id="263" r:id="rId9"/>
-    <p:sldId id="264" r:id="rId10"/>
+    <p:sldId id="265" r:id="rId4"/>
+    <p:sldId id="258" r:id="rId5"/>
+    <p:sldId id="266" r:id="rId6"/>
+    <p:sldId id="267" r:id="rId7"/>
+    <p:sldId id="271" r:id="rId8"/>
+    <p:sldId id="274" r:id="rId9"/>
+    <p:sldId id="270" r:id="rId10"/>
+    <p:sldId id="275" r:id="rId11"/>
+    <p:sldId id="260" r:id="rId12"/>
+    <p:sldId id="261" r:id="rId13"/>
+    <p:sldId id="276" r:id="rId14"/>
+    <p:sldId id="277" r:id="rId15"/>
+    <p:sldId id="263" r:id="rId16"/>
+    <p:sldId id="264" r:id="rId17"/>
   </p:sldIdLst>
   <p:sldSz cx="12192000" cy="6858000"/>
   <p:notesSz cx="6858000" cy="9144000"/>
@@ -3410,7 +3417,7 @@
             <a:pPr algn="l"/>
             <a:r>
               <a:rPr lang="en-CH" dirty="0"/>
-              <a:t>NLP– Sacha Vogel</a:t>
+              <a:t>NLP – Sacha Vogel</a:t>
             </a:r>
           </a:p>
         </p:txBody>
@@ -3419,6 +3426,1877 @@
     <p:extLst>
       <p:ext uri="{BB962C8B-B14F-4D97-AF65-F5344CB8AC3E}">
         <p14:creationId xmlns:p14="http://schemas.microsoft.com/office/powerpoint/2010/main" val="3960561291"/>
+      </p:ext>
+    </p:extLst>
+  </p:cSld>
+  <p:clrMapOvr>
+    <a:masterClrMapping/>
+  </p:clrMapOvr>
+</p:sld>
+</file>
+
+<file path=ppt/slides/slide10.xml><?xml version="1.0" encoding="utf-8"?>
+<p:sld xmlns:a="http://schemas.openxmlformats.org/drawingml/2006/main" xmlns:r="http://schemas.openxmlformats.org/officeDocument/2006/relationships" xmlns:p="http://schemas.openxmlformats.org/presentationml/2006/main">
+  <p:cSld>
+    <p:spTree>
+      <p:nvGrpSpPr>
+        <p:cNvPr id="1" name=""/>
+        <p:cNvGrpSpPr/>
+        <p:nvPr/>
+      </p:nvGrpSpPr>
+      <p:grpSpPr>
+        <a:xfrm>
+          <a:off x="0" y="0"/>
+          <a:ext cx="0" cy="0"/>
+          <a:chOff x="0" y="0"/>
+          <a:chExt cx="0" cy="0"/>
+        </a:xfrm>
+      </p:grpSpPr>
+      <p:sp>
+        <p:nvSpPr>
+          <p:cNvPr id="2" name="Title 1">
+            <a:extLst>
+              <a:ext uri="{FF2B5EF4-FFF2-40B4-BE49-F238E27FC236}">
+                <a16:creationId xmlns:a16="http://schemas.microsoft.com/office/drawing/2014/main" id="{3EB9E692-B047-526E-F9BD-199D47416CF1}"/>
+              </a:ext>
+            </a:extLst>
+          </p:cNvPr>
+          <p:cNvSpPr txBox="1">
+            <a:spLocks/>
+          </p:cNvSpPr>
+          <p:nvPr/>
+        </p:nvSpPr>
+        <p:spPr>
+          <a:xfrm>
+            <a:off x="838200" y="365125"/>
+            <a:ext cx="10515600" cy="1325563"/>
+          </a:xfrm>
+          <a:prstGeom prst="rect">
+            <a:avLst/>
+          </a:prstGeom>
+        </p:spPr>
+        <p:txBody>
+          <a:bodyPr vert="horz" lIns="91440" tIns="45720" rIns="91440" bIns="45720" rtlCol="0" anchor="ctr">
+            <a:normAutofit/>
+          </a:bodyPr>
+          <a:lstStyle>
+            <a:lvl1pPr algn="l" defTabSz="914400" rtl="0" eaLnBrk="1" latinLnBrk="0" hangingPunct="1">
+              <a:lnSpc>
+                <a:spcPct val="90000"/>
+              </a:lnSpc>
+              <a:spcBef>
+                <a:spcPct val="0"/>
+              </a:spcBef>
+              <a:buNone/>
+              <a:defRPr sz="4400" kern="1200">
+                <a:solidFill>
+                  <a:schemeClr val="tx1"/>
+                </a:solidFill>
+                <a:latin typeface="+mj-lt"/>
+                <a:ea typeface="+mj-ea"/>
+                <a:cs typeface="+mj-cs"/>
+              </a:defRPr>
+            </a:lvl1pPr>
+          </a:lstStyle>
+          <a:p>
+            <a:r>
+              <a:rPr lang="en-CH" dirty="0"/>
+              <a:t>Network Architecture LLM</a:t>
+            </a:r>
+          </a:p>
+        </p:txBody>
+      </p:sp>
+      <p:sp>
+        <p:nvSpPr>
+          <p:cNvPr id="4" name="Content Placeholder 2">
+            <a:extLst>
+              <a:ext uri="{FF2B5EF4-FFF2-40B4-BE49-F238E27FC236}">
+                <a16:creationId xmlns:a16="http://schemas.microsoft.com/office/drawing/2014/main" id="{A1D59EFB-2976-D8CA-92FD-AC2BDB4DFF57}"/>
+              </a:ext>
+            </a:extLst>
+          </p:cNvPr>
+          <p:cNvSpPr>
+            <a:spLocks noGrp="1"/>
+          </p:cNvSpPr>
+          <p:nvPr>
+            <p:ph idx="1"/>
+          </p:nvPr>
+        </p:nvSpPr>
+        <p:spPr>
+          <a:xfrm>
+            <a:off x="838199" y="1825625"/>
+            <a:ext cx="6659881" cy="4351338"/>
+          </a:xfrm>
+        </p:spPr>
+        <p:txBody>
+          <a:bodyPr>
+            <a:normAutofit/>
+          </a:bodyPr>
+          <a:lstStyle/>
+          <a:p>
+            <a:pPr marL="0" indent="0">
+              <a:buNone/>
+            </a:pPr>
+            <a:r>
+              <a:rPr lang="en-CH" sz="2200" b="1" dirty="0"/>
+              <a:t>“ARCHITECTURE”</a:t>
+            </a:r>
+          </a:p>
+          <a:p>
+            <a:pPr marL="0" indent="0">
+              <a:buNone/>
+            </a:pPr>
+            <a:r>
+              <a:rPr lang="en-CH" sz="2200" b="1" dirty="0"/>
+              <a:t>	</a:t>
+            </a:r>
+            <a:r>
+              <a:rPr lang="en-GB" sz="2200" dirty="0">
+                <a:solidFill>
+                  <a:srgbClr val="067D17"/>
+                </a:solidFill>
+                <a:effectLst/>
+              </a:rPr>
+              <a:t>Qwen2.5-3B-Instruct</a:t>
+            </a:r>
+          </a:p>
+          <a:p>
+            <a:pPr marL="0" indent="0">
+              <a:buNone/>
+            </a:pPr>
+            <a:r>
+              <a:rPr lang="en-GB" sz="2200" dirty="0">
+                <a:solidFill>
+                  <a:srgbClr val="067D17"/>
+                </a:solidFill>
+              </a:rPr>
+              <a:t>	</a:t>
+            </a:r>
+            <a:r>
+              <a:rPr lang="en-GB" sz="2200" dirty="0"/>
+              <a:t>3B parameters</a:t>
+            </a:r>
+            <a:r>
+              <a:rPr lang="en-GB" sz="2200" b="1" dirty="0">
+                <a:solidFill>
+                  <a:srgbClr val="080808"/>
+                </a:solidFill>
+                <a:effectLst/>
+              </a:rPr>
+              <a:t>	</a:t>
+            </a:r>
+          </a:p>
+        </p:txBody>
+      </p:sp>
+    </p:spTree>
+    <p:extLst>
+      <p:ext uri="{BB962C8B-B14F-4D97-AF65-F5344CB8AC3E}">
+        <p14:creationId xmlns:p14="http://schemas.microsoft.com/office/powerpoint/2010/main" val="1287014141"/>
+      </p:ext>
+    </p:extLst>
+  </p:cSld>
+  <p:clrMapOvr>
+    <a:masterClrMapping/>
+  </p:clrMapOvr>
+</p:sld>
+</file>
+
+<file path=ppt/slides/slide11.xml><?xml version="1.0" encoding="utf-8"?>
+<p:sld xmlns:a="http://schemas.openxmlformats.org/drawingml/2006/main" xmlns:r="http://schemas.openxmlformats.org/officeDocument/2006/relationships" xmlns:p="http://schemas.openxmlformats.org/presentationml/2006/main">
+  <p:cSld>
+    <p:spTree>
+      <p:nvGrpSpPr>
+        <p:cNvPr id="1" name=""/>
+        <p:cNvGrpSpPr/>
+        <p:nvPr/>
+      </p:nvGrpSpPr>
+      <p:grpSpPr>
+        <a:xfrm>
+          <a:off x="0" y="0"/>
+          <a:ext cx="0" cy="0"/>
+          <a:chOff x="0" y="0"/>
+          <a:chExt cx="0" cy="0"/>
+        </a:xfrm>
+      </p:grpSpPr>
+      <p:sp>
+        <p:nvSpPr>
+          <p:cNvPr id="2" name="Title 1">
+            <a:extLst>
+              <a:ext uri="{FF2B5EF4-FFF2-40B4-BE49-F238E27FC236}">
+                <a16:creationId xmlns:a16="http://schemas.microsoft.com/office/drawing/2014/main" id="{97E073E8-A468-A30B-7B45-E2E008616637}"/>
+              </a:ext>
+            </a:extLst>
+          </p:cNvPr>
+          <p:cNvSpPr>
+            <a:spLocks noGrp="1"/>
+          </p:cNvSpPr>
+          <p:nvPr>
+            <p:ph type="title"/>
+          </p:nvPr>
+        </p:nvSpPr>
+        <p:spPr/>
+        <p:txBody>
+          <a:bodyPr/>
+          <a:lstStyle/>
+          <a:p>
+            <a:r>
+              <a:rPr lang="en-CH" dirty="0"/>
+              <a:t>Experiments</a:t>
+            </a:r>
+          </a:p>
+        </p:txBody>
+      </p:sp>
+      <p:sp>
+        <p:nvSpPr>
+          <p:cNvPr id="4" name="Content Placeholder 2">
+            <a:extLst>
+              <a:ext uri="{FF2B5EF4-FFF2-40B4-BE49-F238E27FC236}">
+                <a16:creationId xmlns:a16="http://schemas.microsoft.com/office/drawing/2014/main" id="{0AD585BA-7A05-3F4B-4CCD-0489470A5EEF}"/>
+              </a:ext>
+            </a:extLst>
+          </p:cNvPr>
+          <p:cNvSpPr>
+            <a:spLocks noGrp="1"/>
+          </p:cNvSpPr>
+          <p:nvPr>
+            <p:ph idx="1"/>
+          </p:nvPr>
+        </p:nvSpPr>
+        <p:spPr>
+          <a:xfrm>
+            <a:off x="838199" y="1825625"/>
+            <a:ext cx="10809850" cy="4351338"/>
+          </a:xfrm>
+        </p:spPr>
+        <p:txBody>
+          <a:bodyPr>
+            <a:normAutofit/>
+          </a:bodyPr>
+          <a:lstStyle/>
+          <a:p>
+            <a:pPr marL="0" indent="0">
+              <a:buNone/>
+            </a:pPr>
+            <a:r>
+              <a:rPr lang="en-CH" sz="2200" b="1" dirty="0"/>
+              <a:t>PRETRAINED TRANSFORMER</a:t>
+            </a:r>
+          </a:p>
+          <a:p>
+            <a:pPr marL="0" indent="0">
+              <a:buNone/>
+            </a:pPr>
+            <a:r>
+              <a:rPr lang="en-CH" sz="2200" b="1" dirty="0"/>
+              <a:t>	</a:t>
+            </a:r>
+            <a:r>
+              <a:rPr lang="en-CH" sz="2200" dirty="0"/>
+              <a:t>add </a:t>
+            </a:r>
+            <a:r>
+              <a:rPr lang="en-GB" sz="2200" b="1" dirty="0" err="1"/>
+              <a:t>OneCycleLR</a:t>
+            </a:r>
+            <a:r>
+              <a:rPr lang="en-GB" sz="2200" b="1" dirty="0"/>
+              <a:t> </a:t>
+            </a:r>
+            <a:r>
+              <a:rPr lang="en-GB" sz="2200" dirty="0"/>
+              <a:t>scheduler after low regularization</a:t>
+            </a:r>
+            <a:endParaRPr lang="en-CH" sz="2200" b="1" dirty="0"/>
+          </a:p>
+          <a:p>
+            <a:pPr marL="0" indent="0">
+              <a:buNone/>
+            </a:pPr>
+            <a:endParaRPr lang="en-CH" sz="2200" b="1" dirty="0"/>
+          </a:p>
+          <a:p>
+            <a:pPr marL="0" indent="0">
+              <a:buNone/>
+            </a:pPr>
+            <a:r>
+              <a:rPr lang="en-CH" sz="2200" b="1" dirty="0"/>
+              <a:t>LLM</a:t>
+            </a:r>
+          </a:p>
+          <a:p>
+            <a:pPr marL="0" indent="0">
+              <a:buNone/>
+            </a:pPr>
+            <a:r>
+              <a:rPr lang="en-CH" sz="2200" b="1" dirty="0"/>
+              <a:t>	</a:t>
+            </a:r>
+            <a:r>
+              <a:rPr lang="en-CH" sz="2200" dirty="0"/>
+              <a:t>switched from </a:t>
+            </a:r>
+            <a:r>
+              <a:rPr lang="en-GB" sz="2200" dirty="0">
+                <a:solidFill>
+                  <a:srgbClr val="067D17"/>
+                </a:solidFill>
+                <a:effectLst/>
+              </a:rPr>
+              <a:t>Qwen2.5-</a:t>
+            </a:r>
+            <a:r>
+              <a:rPr lang="en-GB" sz="2200" b="1" dirty="0">
+                <a:solidFill>
+                  <a:srgbClr val="067D17"/>
+                </a:solidFill>
+                <a:effectLst/>
+              </a:rPr>
+              <a:t>1.5B</a:t>
+            </a:r>
+            <a:r>
+              <a:rPr lang="en-GB" sz="2200" dirty="0">
+                <a:solidFill>
+                  <a:srgbClr val="067D17"/>
+                </a:solidFill>
+                <a:effectLst/>
+              </a:rPr>
+              <a:t>-Instruct </a:t>
+            </a:r>
+            <a:r>
+              <a:rPr lang="en-GB" sz="2200" dirty="0">
+                <a:effectLst/>
+              </a:rPr>
+              <a:t>to </a:t>
+            </a:r>
+            <a:r>
+              <a:rPr lang="en-GB" sz="2200" dirty="0">
+                <a:solidFill>
+                  <a:srgbClr val="067D17"/>
+                </a:solidFill>
+                <a:effectLst/>
+              </a:rPr>
+              <a:t>Qwen2.5-</a:t>
+            </a:r>
+            <a:r>
+              <a:rPr lang="en-GB" sz="2200" b="1" dirty="0">
+                <a:solidFill>
+                  <a:srgbClr val="067D17"/>
+                </a:solidFill>
+                <a:effectLst/>
+              </a:rPr>
+              <a:t>3B</a:t>
+            </a:r>
+            <a:r>
+              <a:rPr lang="en-GB" sz="2200" dirty="0">
+                <a:solidFill>
+                  <a:srgbClr val="067D17"/>
+                </a:solidFill>
+                <a:effectLst/>
+              </a:rPr>
+              <a:t>-Instruct</a:t>
+            </a:r>
+            <a:endParaRPr lang="en-CH" sz="2200" b="1" dirty="0"/>
+          </a:p>
+          <a:p>
+            <a:pPr marL="0" indent="0">
+              <a:buNone/>
+            </a:pPr>
+            <a:r>
+              <a:rPr lang="en-CH" sz="2200" b="1" dirty="0"/>
+              <a:t>	</a:t>
+            </a:r>
+            <a:r>
+              <a:rPr lang="en-CH" sz="2200" dirty="0"/>
+              <a:t>try second prompt with specific role assignment</a:t>
+            </a:r>
+            <a:endParaRPr lang="en-CH" sz="2200" b="1" dirty="0"/>
+          </a:p>
+          <a:p>
+            <a:pPr marL="0" indent="0">
+              <a:buNone/>
+            </a:pPr>
+            <a:r>
+              <a:rPr lang="en-CH" sz="2200" b="1" dirty="0"/>
+              <a:t>	</a:t>
+            </a:r>
+            <a:r>
+              <a:rPr lang="de-CH" sz="2200" dirty="0" err="1"/>
+              <a:t>answer</a:t>
+            </a:r>
+            <a:r>
+              <a:rPr lang="de-CH" sz="2200" dirty="0"/>
+              <a:t> </a:t>
+            </a:r>
+            <a:r>
+              <a:rPr lang="de-CH" sz="2200" dirty="0" err="1"/>
+              <a:t>with</a:t>
+            </a:r>
+            <a:r>
+              <a:rPr lang="de-CH" sz="2200" dirty="0"/>
+              <a:t> «A» and «B» </a:t>
+            </a:r>
+            <a:r>
+              <a:rPr lang="de-CH" sz="2200" dirty="0" err="1"/>
+              <a:t>instead</a:t>
+            </a:r>
+            <a:r>
+              <a:rPr lang="de-CH" sz="2200" dirty="0"/>
+              <a:t> </a:t>
+            </a:r>
+            <a:r>
+              <a:rPr lang="de-CH" sz="2200" dirty="0" err="1"/>
+              <a:t>of</a:t>
+            </a:r>
+            <a:r>
+              <a:rPr lang="de-CH" sz="2200" dirty="0"/>
+              <a:t> «0» and «1» </a:t>
+            </a:r>
+            <a:r>
+              <a:rPr lang="de-CH" sz="2200" dirty="0" err="1"/>
+              <a:t>improved</a:t>
+            </a:r>
+            <a:r>
+              <a:rPr lang="de-CH" sz="2200" dirty="0"/>
+              <a:t> </a:t>
+            </a:r>
+            <a:r>
+              <a:rPr lang="de-CH" sz="2200" dirty="0" err="1"/>
+              <a:t>performance</a:t>
+            </a:r>
+            <a:endParaRPr lang="en-CH" sz="2200" dirty="0"/>
+          </a:p>
+        </p:txBody>
+      </p:sp>
+    </p:spTree>
+    <p:extLst>
+      <p:ext uri="{BB962C8B-B14F-4D97-AF65-F5344CB8AC3E}">
+        <p14:creationId xmlns:p14="http://schemas.microsoft.com/office/powerpoint/2010/main" val="2976245617"/>
+      </p:ext>
+    </p:extLst>
+  </p:cSld>
+  <p:clrMapOvr>
+    <a:masterClrMapping/>
+  </p:clrMapOvr>
+</p:sld>
+</file>
+
+<file path=ppt/slides/slide12.xml><?xml version="1.0" encoding="utf-8"?>
+<p:sld xmlns:a="http://schemas.openxmlformats.org/drawingml/2006/main" xmlns:r="http://schemas.openxmlformats.org/officeDocument/2006/relationships" xmlns:p="http://schemas.openxmlformats.org/presentationml/2006/main">
+  <p:cSld>
+    <p:spTree>
+      <p:nvGrpSpPr>
+        <p:cNvPr id="1" name=""/>
+        <p:cNvGrpSpPr/>
+        <p:nvPr/>
+      </p:nvGrpSpPr>
+      <p:grpSpPr>
+        <a:xfrm>
+          <a:off x="0" y="0"/>
+          <a:ext cx="0" cy="0"/>
+          <a:chOff x="0" y="0"/>
+          <a:chExt cx="0" cy="0"/>
+        </a:xfrm>
+      </p:grpSpPr>
+      <p:sp>
+        <p:nvSpPr>
+          <p:cNvPr id="2" name="Title 1">
+            <a:extLst>
+              <a:ext uri="{FF2B5EF4-FFF2-40B4-BE49-F238E27FC236}">
+                <a16:creationId xmlns:a16="http://schemas.microsoft.com/office/drawing/2014/main" id="{97E073E8-A468-A30B-7B45-E2E008616637}"/>
+              </a:ext>
+            </a:extLst>
+          </p:cNvPr>
+          <p:cNvSpPr>
+            <a:spLocks noGrp="1"/>
+          </p:cNvSpPr>
+          <p:nvPr>
+            <p:ph type="title"/>
+          </p:nvPr>
+        </p:nvSpPr>
+        <p:spPr/>
+        <p:txBody>
+          <a:bodyPr/>
+          <a:lstStyle/>
+          <a:p>
+            <a:r>
+              <a:rPr lang="en-CH" dirty="0"/>
+              <a:t>Results</a:t>
+            </a:r>
+          </a:p>
+        </p:txBody>
+      </p:sp>
+      <p:graphicFrame>
+        <p:nvGraphicFramePr>
+          <p:cNvPr id="4" name="Content Placeholder 3">
+            <a:extLst>
+              <a:ext uri="{FF2B5EF4-FFF2-40B4-BE49-F238E27FC236}">
+                <a16:creationId xmlns:a16="http://schemas.microsoft.com/office/drawing/2014/main" id="{7FED4360-A5C2-82D2-160F-48D286277966}"/>
+              </a:ext>
+            </a:extLst>
+          </p:cNvPr>
+          <p:cNvGraphicFramePr>
+            <a:graphicFrameLocks noGrp="1"/>
+          </p:cNvGraphicFramePr>
+          <p:nvPr>
+            <p:ph idx="1"/>
+            <p:extLst>
+              <p:ext uri="{D42A27DB-BD31-4B8C-83A1-F6EECF244321}">
+                <p14:modId xmlns:p14="http://schemas.microsoft.com/office/powerpoint/2010/main" val="3609794237"/>
+              </p:ext>
+            </p:extLst>
+          </p:nvPr>
+        </p:nvGraphicFramePr>
+        <p:xfrm>
+          <a:off x="838200" y="1768475"/>
+          <a:ext cx="10515600" cy="3718560"/>
+        </p:xfrm>
+        <a:graphic>
+          <a:graphicData uri="http://schemas.openxmlformats.org/drawingml/2006/table">
+            <a:tbl>
+              <a:tblPr firstRow="1" bandRow="1">
+                <a:tableStyleId>{9D7B26C5-4107-4FEC-AEDC-1716B250A1EF}</a:tableStyleId>
+              </a:tblPr>
+              <a:tblGrid>
+                <a:gridCol w="3396175">
+                  <a:extLst>
+                    <a:ext uri="{9D8B030D-6E8A-4147-A177-3AD203B41FA5}">
+                      <a16:colId xmlns:a16="http://schemas.microsoft.com/office/drawing/2014/main" val="953994096"/>
+                    </a:ext>
+                  </a:extLst>
+                </a:gridCol>
+                <a:gridCol w="2307102">
+                  <a:extLst>
+                    <a:ext uri="{9D8B030D-6E8A-4147-A177-3AD203B41FA5}">
+                      <a16:colId xmlns:a16="http://schemas.microsoft.com/office/drawing/2014/main" val="2341483827"/>
+                    </a:ext>
+                  </a:extLst>
+                </a:gridCol>
+                <a:gridCol w="2489981">
+                  <a:extLst>
+                    <a:ext uri="{9D8B030D-6E8A-4147-A177-3AD203B41FA5}">
+                      <a16:colId xmlns:a16="http://schemas.microsoft.com/office/drawing/2014/main" val="2574548658"/>
+                    </a:ext>
+                  </a:extLst>
+                </a:gridCol>
+                <a:gridCol w="2322342">
+                  <a:extLst>
+                    <a:ext uri="{9D8B030D-6E8A-4147-A177-3AD203B41FA5}">
+                      <a16:colId xmlns:a16="http://schemas.microsoft.com/office/drawing/2014/main" val="1423803622"/>
+                    </a:ext>
+                  </a:extLst>
+                </a:gridCol>
+              </a:tblGrid>
+              <a:tr h="370840">
+                <a:tc>
+                  <a:txBody>
+                    <a:bodyPr/>
+                    <a:lstStyle/>
+                    <a:p>
+                      <a:r>
+                        <a:rPr lang="en-CH" sz="2200" dirty="0"/>
+                        <a:t>MODEL</a:t>
+                      </a:r>
+                    </a:p>
+                  </a:txBody>
+                  <a:tcPr>
+                    <a:lnL>
+                      <a:noFill/>
+                    </a:lnL>
+                    <a:lnR>
+                      <a:noFill/>
+                    </a:lnR>
+                    <a:lnT w="12700" cmpd="sng">
+                      <a:noFill/>
+                    </a:lnT>
+                    <a:lnB w="12700" cmpd="sng">
+                      <a:noFill/>
+                    </a:lnB>
+                    <a:lnTlToBr w="12700" cmpd="sng">
+                      <a:noFill/>
+                      <a:prstDash val="solid"/>
+                    </a:lnTlToBr>
+                    <a:lnBlToTr w="12700" cmpd="sng">
+                      <a:noFill/>
+                      <a:prstDash val="solid"/>
+                    </a:lnBlToTr>
+                  </a:tcPr>
+                </a:tc>
+                <a:tc>
+                  <a:txBody>
+                    <a:bodyPr/>
+                    <a:lstStyle/>
+                    <a:p>
+                      <a:r>
+                        <a:rPr lang="en-CH" sz="2200" dirty="0"/>
+                        <a:t>TRAINING SET ACCURACY</a:t>
+                      </a:r>
+                    </a:p>
+                  </a:txBody>
+                  <a:tcPr>
+                    <a:lnL>
+                      <a:noFill/>
+                    </a:lnL>
+                    <a:lnR>
+                      <a:noFill/>
+                    </a:lnR>
+                    <a:lnT w="12700" cmpd="sng">
+                      <a:noFill/>
+                    </a:lnT>
+                    <a:lnB w="12700" cmpd="sng">
+                      <a:noFill/>
+                    </a:lnB>
+                    <a:lnTlToBr w="12700" cmpd="sng">
+                      <a:noFill/>
+                      <a:prstDash val="solid"/>
+                    </a:lnTlToBr>
+                    <a:lnBlToTr w="12700" cmpd="sng">
+                      <a:noFill/>
+                      <a:prstDash val="solid"/>
+                    </a:lnBlToTr>
+                  </a:tcPr>
+                </a:tc>
+                <a:tc>
+                  <a:txBody>
+                    <a:bodyPr/>
+                    <a:lstStyle/>
+                    <a:p>
+                      <a:r>
+                        <a:rPr lang="en-CH" sz="2200" dirty="0"/>
+                        <a:t>VALIDATION SET ACCURACY</a:t>
+                      </a:r>
+                    </a:p>
+                  </a:txBody>
+                  <a:tcPr>
+                    <a:lnL>
+                      <a:noFill/>
+                    </a:lnL>
+                    <a:lnR>
+                      <a:noFill/>
+                    </a:lnR>
+                    <a:lnT w="12700" cmpd="sng">
+                      <a:noFill/>
+                    </a:lnT>
+                    <a:lnB w="12700" cmpd="sng">
+                      <a:noFill/>
+                    </a:lnB>
+                    <a:lnTlToBr w="12700" cmpd="sng">
+                      <a:noFill/>
+                      <a:prstDash val="solid"/>
+                    </a:lnTlToBr>
+                    <a:lnBlToTr w="12700" cmpd="sng">
+                      <a:noFill/>
+                      <a:prstDash val="solid"/>
+                    </a:lnBlToTr>
+                  </a:tcPr>
+                </a:tc>
+                <a:tc>
+                  <a:txBody>
+                    <a:bodyPr/>
+                    <a:lstStyle/>
+                    <a:p>
+                      <a:r>
+                        <a:rPr lang="en-CH" sz="2200" dirty="0"/>
+                        <a:t>TEST SET ACCURACY</a:t>
+                      </a:r>
+                    </a:p>
+                  </a:txBody>
+                  <a:tcPr>
+                    <a:lnL>
+                      <a:noFill/>
+                    </a:lnL>
+                    <a:lnR>
+                      <a:noFill/>
+                    </a:lnR>
+                    <a:lnT w="12700" cmpd="sng">
+                      <a:noFill/>
+                    </a:lnT>
+                    <a:lnB w="12700" cmpd="sng">
+                      <a:noFill/>
+                    </a:lnB>
+                    <a:lnTlToBr w="12700" cmpd="sng">
+                      <a:noFill/>
+                      <a:prstDash val="solid"/>
+                    </a:lnTlToBr>
+                    <a:lnBlToTr w="12700" cmpd="sng">
+                      <a:noFill/>
+                      <a:prstDash val="solid"/>
+                    </a:lnBlToTr>
+                  </a:tcPr>
+                </a:tc>
+                <a:extLst>
+                  <a:ext uri="{0D108BD9-81ED-4DB2-BD59-A6C34878D82A}">
+                    <a16:rowId xmlns:a16="http://schemas.microsoft.com/office/drawing/2014/main" val="2936785088"/>
+                  </a:ext>
+                </a:extLst>
+              </a:tr>
+              <a:tr h="370840">
+                <a:tc>
+                  <a:txBody>
+                    <a:bodyPr/>
+                    <a:lstStyle/>
+                    <a:p>
+                      <a:r>
+                        <a:rPr lang="en-CH" sz="2200" dirty="0"/>
+                        <a:t>Random Initialized BERT</a:t>
+                      </a:r>
+                    </a:p>
+                    <a:p>
+                      <a:endParaRPr lang="en-CH" sz="2200" dirty="0"/>
+                    </a:p>
+                  </a:txBody>
+                  <a:tcPr>
+                    <a:lnL>
+                      <a:noFill/>
+                    </a:lnL>
+                    <a:lnR>
+                      <a:noFill/>
+                    </a:lnR>
+                    <a:lnT w="12700" cmpd="sng">
+                      <a:noFill/>
+                    </a:lnT>
+                    <a:lnB>
+                      <a:noFill/>
+                    </a:lnB>
+                    <a:lnTlToBr w="12700" cmpd="sng">
+                      <a:noFill/>
+                      <a:prstDash val="solid"/>
+                    </a:lnTlToBr>
+                    <a:lnBlToTr w="12700" cmpd="sng">
+                      <a:noFill/>
+                      <a:prstDash val="solid"/>
+                    </a:lnBlToTr>
+                  </a:tcPr>
+                </a:tc>
+                <a:tc>
+                  <a:txBody>
+                    <a:bodyPr/>
+                    <a:lstStyle/>
+                    <a:p>
+                      <a:pPr algn="r"/>
+                      <a:endParaRPr lang="en-CH" sz="2200" dirty="0"/>
+                    </a:p>
+                    <a:p>
+                      <a:pPr algn="r"/>
+                      <a:r>
+                        <a:rPr lang="en-CH" sz="2200" dirty="0"/>
+                        <a:t>0.504</a:t>
+                      </a:r>
+                    </a:p>
+                  </a:txBody>
+                  <a:tcPr>
+                    <a:lnL>
+                      <a:noFill/>
+                    </a:lnL>
+                    <a:lnR>
+                      <a:noFill/>
+                    </a:lnR>
+                    <a:lnT w="12700" cmpd="sng">
+                      <a:noFill/>
+                    </a:lnT>
+                    <a:lnB>
+                      <a:noFill/>
+                    </a:lnB>
+                    <a:lnTlToBr w="12700" cmpd="sng">
+                      <a:noFill/>
+                      <a:prstDash val="solid"/>
+                    </a:lnTlToBr>
+                    <a:lnBlToTr w="12700" cmpd="sng">
+                      <a:noFill/>
+                      <a:prstDash val="solid"/>
+                    </a:lnBlToTr>
+                  </a:tcPr>
+                </a:tc>
+                <a:tc>
+                  <a:txBody>
+                    <a:bodyPr/>
+                    <a:lstStyle/>
+                    <a:p>
+                      <a:pPr algn="r"/>
+                      <a:endParaRPr lang="en-CH" sz="2200" dirty="0"/>
+                    </a:p>
+                    <a:p>
+                      <a:pPr algn="r"/>
+                      <a:r>
+                        <a:rPr lang="en-CH" sz="2200" dirty="0"/>
+                        <a:t>0.517</a:t>
+                      </a:r>
+                    </a:p>
+                  </a:txBody>
+                  <a:tcPr>
+                    <a:lnL>
+                      <a:noFill/>
+                    </a:lnL>
+                    <a:lnR>
+                      <a:noFill/>
+                    </a:lnR>
+                    <a:lnT w="12700" cmpd="sng">
+                      <a:noFill/>
+                    </a:lnT>
+                    <a:lnB>
+                      <a:noFill/>
+                    </a:lnB>
+                    <a:lnTlToBr w="12700" cmpd="sng">
+                      <a:noFill/>
+                      <a:prstDash val="solid"/>
+                    </a:lnTlToBr>
+                    <a:lnBlToTr w="12700" cmpd="sng">
+                      <a:noFill/>
+                      <a:prstDash val="solid"/>
+                    </a:lnBlToTr>
+                  </a:tcPr>
+                </a:tc>
+                <a:tc>
+                  <a:txBody>
+                    <a:bodyPr/>
+                    <a:lstStyle/>
+                    <a:p>
+                      <a:pPr algn="r"/>
+                      <a:endParaRPr lang="en-CH" sz="2200" dirty="0"/>
+                    </a:p>
+                    <a:p>
+                      <a:pPr algn="r"/>
+                      <a:r>
+                        <a:rPr lang="en-CH" sz="2200" dirty="0"/>
+                        <a:t>0.496</a:t>
+                      </a:r>
+                    </a:p>
+                  </a:txBody>
+                  <a:tcPr>
+                    <a:lnL>
+                      <a:noFill/>
+                    </a:lnL>
+                    <a:lnR>
+                      <a:noFill/>
+                    </a:lnR>
+                    <a:lnT w="12700" cmpd="sng">
+                      <a:noFill/>
+                    </a:lnT>
+                    <a:lnB>
+                      <a:noFill/>
+                    </a:lnB>
+                    <a:lnTlToBr w="12700" cmpd="sng">
+                      <a:noFill/>
+                      <a:prstDash val="solid"/>
+                    </a:lnTlToBr>
+                    <a:lnBlToTr w="12700" cmpd="sng">
+                      <a:noFill/>
+                      <a:prstDash val="solid"/>
+                    </a:lnBlToTr>
+                  </a:tcPr>
+                </a:tc>
+                <a:extLst>
+                  <a:ext uri="{0D108BD9-81ED-4DB2-BD59-A6C34878D82A}">
+                    <a16:rowId xmlns:a16="http://schemas.microsoft.com/office/drawing/2014/main" val="563072786"/>
+                  </a:ext>
+                </a:extLst>
+              </a:tr>
+              <a:tr h="370840">
+                <a:tc>
+                  <a:txBody>
+                    <a:bodyPr/>
+                    <a:lstStyle/>
+                    <a:p>
+                      <a:r>
+                        <a:rPr lang="en-CH" sz="2200" dirty="0"/>
+                        <a:t>Pretrained BERT </a:t>
+                      </a:r>
+                    </a:p>
+                    <a:p>
+                      <a:r>
+                        <a:rPr lang="en-CH" sz="2200" dirty="0"/>
+                        <a:t>(bert-base-uncased)</a:t>
+                      </a:r>
+                    </a:p>
+                    <a:p>
+                      <a:endParaRPr lang="en-CH" sz="2200" dirty="0"/>
+                    </a:p>
+                  </a:txBody>
+                  <a:tcPr>
+                    <a:lnL>
+                      <a:noFill/>
+                    </a:lnL>
+                    <a:lnR>
+                      <a:noFill/>
+                    </a:lnR>
+                    <a:lnT>
+                      <a:noFill/>
+                    </a:lnT>
+                    <a:lnB>
+                      <a:noFill/>
+                    </a:lnB>
+                    <a:lnTlToBr w="12700" cmpd="sng">
+                      <a:noFill/>
+                      <a:prstDash val="solid"/>
+                    </a:lnTlToBr>
+                    <a:lnBlToTr w="12700" cmpd="sng">
+                      <a:noFill/>
+                      <a:prstDash val="solid"/>
+                    </a:lnBlToTr>
+                  </a:tcPr>
+                </a:tc>
+                <a:tc>
+                  <a:txBody>
+                    <a:bodyPr/>
+                    <a:lstStyle/>
+                    <a:p>
+                      <a:pPr algn="r"/>
+                      <a:endParaRPr lang="en-CH" sz="2200" dirty="0"/>
+                    </a:p>
+                    <a:p>
+                      <a:pPr algn="r"/>
+                      <a:r>
+                        <a:rPr lang="en-CH" sz="2200" dirty="0"/>
+                        <a:t>0.956</a:t>
+                      </a:r>
+                    </a:p>
+                  </a:txBody>
+                  <a:tcPr>
+                    <a:lnL>
+                      <a:noFill/>
+                    </a:lnL>
+                    <a:lnR>
+                      <a:noFill/>
+                    </a:lnR>
+                    <a:lnT>
+                      <a:noFill/>
+                    </a:lnT>
+                    <a:lnB>
+                      <a:noFill/>
+                    </a:lnB>
+                    <a:lnTlToBr w="12700" cmpd="sng">
+                      <a:noFill/>
+                      <a:prstDash val="solid"/>
+                    </a:lnTlToBr>
+                    <a:lnBlToTr w="12700" cmpd="sng">
+                      <a:noFill/>
+                      <a:prstDash val="solid"/>
+                    </a:lnBlToTr>
+                  </a:tcPr>
+                </a:tc>
+                <a:tc>
+                  <a:txBody>
+                    <a:bodyPr/>
+                    <a:lstStyle/>
+                    <a:p>
+                      <a:pPr algn="r"/>
+                      <a:endParaRPr lang="en-CH" sz="2200" dirty="0"/>
+                    </a:p>
+                    <a:p>
+                      <a:pPr algn="r"/>
+                      <a:r>
+                        <a:rPr lang="en-CH" sz="2200" dirty="0"/>
+                        <a:t>0.668</a:t>
+                      </a:r>
+                    </a:p>
+                  </a:txBody>
+                  <a:tcPr>
+                    <a:lnL>
+                      <a:noFill/>
+                    </a:lnL>
+                    <a:lnR>
+                      <a:noFill/>
+                    </a:lnR>
+                    <a:lnT>
+                      <a:noFill/>
+                    </a:lnT>
+                    <a:lnB>
+                      <a:noFill/>
+                    </a:lnB>
+                    <a:lnTlToBr w="12700" cmpd="sng">
+                      <a:noFill/>
+                      <a:prstDash val="solid"/>
+                    </a:lnTlToBr>
+                    <a:lnBlToTr w="12700" cmpd="sng">
+                      <a:noFill/>
+                      <a:prstDash val="solid"/>
+                    </a:lnBlToTr>
+                  </a:tcPr>
+                </a:tc>
+                <a:tc>
+                  <a:txBody>
+                    <a:bodyPr/>
+                    <a:lstStyle/>
+                    <a:p>
+                      <a:pPr algn="r"/>
+                      <a:endParaRPr lang="en-CH" sz="2200" dirty="0"/>
+                    </a:p>
+                    <a:p>
+                      <a:pPr algn="r"/>
+                      <a:r>
+                        <a:rPr lang="en-CH" sz="2200" dirty="0"/>
+                        <a:t>0.656</a:t>
+                      </a:r>
+                    </a:p>
+                  </a:txBody>
+                  <a:tcPr>
+                    <a:lnL>
+                      <a:noFill/>
+                    </a:lnL>
+                    <a:lnR>
+                      <a:noFill/>
+                    </a:lnR>
+                    <a:lnT>
+                      <a:noFill/>
+                    </a:lnT>
+                    <a:lnB>
+                      <a:noFill/>
+                    </a:lnB>
+                    <a:lnTlToBr w="12700" cmpd="sng">
+                      <a:noFill/>
+                      <a:prstDash val="solid"/>
+                    </a:lnTlToBr>
+                    <a:lnBlToTr w="12700" cmpd="sng">
+                      <a:noFill/>
+                      <a:prstDash val="solid"/>
+                    </a:lnBlToTr>
+                  </a:tcPr>
+                </a:tc>
+                <a:extLst>
+                  <a:ext uri="{0D108BD9-81ED-4DB2-BD59-A6C34878D82A}">
+                    <a16:rowId xmlns:a16="http://schemas.microsoft.com/office/drawing/2014/main" val="2433388229"/>
+                  </a:ext>
+                </a:extLst>
+              </a:tr>
+              <a:tr h="370840">
+                <a:tc>
+                  <a:txBody>
+                    <a:bodyPr/>
+                    <a:lstStyle/>
+                    <a:p>
+                      <a:r>
+                        <a:rPr lang="en-CH" sz="2200" dirty="0"/>
+                        <a:t>LLM </a:t>
+                      </a:r>
+                    </a:p>
+                    <a:p>
+                      <a:r>
+                        <a:rPr lang="en-GB" sz="2200" dirty="0">
+                          <a:solidFill>
+                            <a:srgbClr val="080808"/>
+                          </a:solidFill>
+                          <a:effectLst/>
+                        </a:rPr>
+                        <a:t>(Qwen2.5-3B-Instruct)</a:t>
+                      </a:r>
+                    </a:p>
+                    <a:p>
+                      <a:endParaRPr lang="en-CH" sz="2200" dirty="0"/>
+                    </a:p>
+                  </a:txBody>
+                  <a:tcPr>
+                    <a:lnL>
+                      <a:noFill/>
+                    </a:lnL>
+                    <a:lnR>
+                      <a:noFill/>
+                    </a:lnR>
+                    <a:lnT>
+                      <a:noFill/>
+                    </a:lnT>
+                    <a:lnB w="12700" cmpd="sng">
+                      <a:noFill/>
+                    </a:lnB>
+                    <a:lnTlToBr w="12700" cmpd="sng">
+                      <a:noFill/>
+                      <a:prstDash val="solid"/>
+                    </a:lnTlToBr>
+                    <a:lnBlToTr w="12700" cmpd="sng">
+                      <a:noFill/>
+                      <a:prstDash val="solid"/>
+                    </a:lnBlToTr>
+                  </a:tcPr>
+                </a:tc>
+                <a:tc>
+                  <a:txBody>
+                    <a:bodyPr/>
+                    <a:lstStyle/>
+                    <a:p>
+                      <a:pPr algn="r"/>
+                      <a:endParaRPr lang="en-CH" sz="2200" dirty="0"/>
+                    </a:p>
+                    <a:p>
+                      <a:pPr algn="r"/>
+                      <a:r>
+                        <a:rPr lang="en-CH" sz="2200" dirty="0"/>
+                        <a:t>-</a:t>
+                      </a:r>
+                    </a:p>
+                  </a:txBody>
+                  <a:tcPr>
+                    <a:lnL>
+                      <a:noFill/>
+                    </a:lnL>
+                    <a:lnR>
+                      <a:noFill/>
+                    </a:lnR>
+                    <a:lnT>
+                      <a:noFill/>
+                    </a:lnT>
+                    <a:lnB w="12700" cmpd="sng">
+                      <a:noFill/>
+                    </a:lnB>
+                    <a:lnTlToBr w="12700" cmpd="sng">
+                      <a:noFill/>
+                      <a:prstDash val="solid"/>
+                    </a:lnTlToBr>
+                    <a:lnBlToTr w="12700" cmpd="sng">
+                      <a:noFill/>
+                      <a:prstDash val="solid"/>
+                    </a:lnBlToTr>
+                  </a:tcPr>
+                </a:tc>
+                <a:tc>
+                  <a:txBody>
+                    <a:bodyPr/>
+                    <a:lstStyle/>
+                    <a:p>
+                      <a:pPr algn="r"/>
+                      <a:endParaRPr lang="en-CH" sz="2200" dirty="0"/>
+                    </a:p>
+                    <a:p>
+                      <a:pPr algn="r"/>
+                      <a:r>
+                        <a:rPr lang="en-CH" sz="2200" dirty="0"/>
+                        <a:t>-</a:t>
+                      </a:r>
+                    </a:p>
+                  </a:txBody>
+                  <a:tcPr>
+                    <a:lnL>
+                      <a:noFill/>
+                    </a:lnL>
+                    <a:lnR>
+                      <a:noFill/>
+                    </a:lnR>
+                    <a:lnT>
+                      <a:noFill/>
+                    </a:lnT>
+                    <a:lnB w="12700" cmpd="sng">
+                      <a:noFill/>
+                    </a:lnB>
+                    <a:lnTlToBr w="12700" cmpd="sng">
+                      <a:noFill/>
+                      <a:prstDash val="solid"/>
+                    </a:lnTlToBr>
+                    <a:lnBlToTr w="12700" cmpd="sng">
+                      <a:noFill/>
+                      <a:prstDash val="solid"/>
+                    </a:lnBlToTr>
+                  </a:tcPr>
+                </a:tc>
+                <a:tc>
+                  <a:txBody>
+                    <a:bodyPr/>
+                    <a:lstStyle/>
+                    <a:p>
+                      <a:pPr algn="r"/>
+                      <a:endParaRPr lang="en-CH" sz="2200" dirty="0"/>
+                    </a:p>
+                    <a:p>
+                      <a:pPr algn="r"/>
+                      <a:r>
+                        <a:rPr lang="en-CH" sz="2200" dirty="0"/>
+                        <a:t>0.753</a:t>
+                      </a:r>
+                    </a:p>
+                  </a:txBody>
+                  <a:tcPr>
+                    <a:lnL>
+                      <a:noFill/>
+                    </a:lnL>
+                    <a:lnR>
+                      <a:noFill/>
+                    </a:lnR>
+                    <a:lnT>
+                      <a:noFill/>
+                    </a:lnT>
+                    <a:lnB w="12700" cmpd="sng">
+                      <a:noFill/>
+                    </a:lnB>
+                    <a:lnTlToBr w="12700" cmpd="sng">
+                      <a:noFill/>
+                      <a:prstDash val="solid"/>
+                    </a:lnTlToBr>
+                    <a:lnBlToTr w="12700" cmpd="sng">
+                      <a:noFill/>
+                      <a:prstDash val="solid"/>
+                    </a:lnBlToTr>
+                  </a:tcPr>
+                </a:tc>
+                <a:extLst>
+                  <a:ext uri="{0D108BD9-81ED-4DB2-BD59-A6C34878D82A}">
+                    <a16:rowId xmlns:a16="http://schemas.microsoft.com/office/drawing/2014/main" val="550076995"/>
+                  </a:ext>
+                </a:extLst>
+              </a:tr>
+            </a:tbl>
+          </a:graphicData>
+        </a:graphic>
+      </p:graphicFrame>
+    </p:spTree>
+    <p:extLst>
+      <p:ext uri="{BB962C8B-B14F-4D97-AF65-F5344CB8AC3E}">
+        <p14:creationId xmlns:p14="http://schemas.microsoft.com/office/powerpoint/2010/main" val="2279130297"/>
+      </p:ext>
+    </p:extLst>
+  </p:cSld>
+  <p:clrMapOvr>
+    <a:masterClrMapping/>
+  </p:clrMapOvr>
+</p:sld>
+</file>
+
+<file path=ppt/slides/slide13.xml><?xml version="1.0" encoding="utf-8"?>
+<p:sld xmlns:a="http://schemas.openxmlformats.org/drawingml/2006/main" xmlns:r="http://schemas.openxmlformats.org/officeDocument/2006/relationships" xmlns:p="http://schemas.openxmlformats.org/presentationml/2006/main">
+  <p:cSld>
+    <p:spTree>
+      <p:nvGrpSpPr>
+        <p:cNvPr id="1" name=""/>
+        <p:cNvGrpSpPr/>
+        <p:nvPr/>
+      </p:nvGrpSpPr>
+      <p:grpSpPr>
+        <a:xfrm>
+          <a:off x="0" y="0"/>
+          <a:ext cx="0" cy="0"/>
+          <a:chOff x="0" y="0"/>
+          <a:chExt cx="0" cy="0"/>
+        </a:xfrm>
+      </p:grpSpPr>
+      <p:sp>
+        <p:nvSpPr>
+          <p:cNvPr id="2" name="Title 1">
+            <a:extLst>
+              <a:ext uri="{FF2B5EF4-FFF2-40B4-BE49-F238E27FC236}">
+                <a16:creationId xmlns:a16="http://schemas.microsoft.com/office/drawing/2014/main" id="{97E073E8-A468-A30B-7B45-E2E008616637}"/>
+              </a:ext>
+            </a:extLst>
+          </p:cNvPr>
+          <p:cNvSpPr>
+            <a:spLocks noGrp="1"/>
+          </p:cNvSpPr>
+          <p:nvPr>
+            <p:ph type="title"/>
+          </p:nvPr>
+        </p:nvSpPr>
+        <p:spPr/>
+        <p:txBody>
+          <a:bodyPr/>
+          <a:lstStyle/>
+          <a:p>
+            <a:r>
+              <a:rPr lang="en-CH" dirty="0"/>
+              <a:t>Interpretation</a:t>
+            </a:r>
+          </a:p>
+        </p:txBody>
+      </p:sp>
+      <p:sp>
+        <p:nvSpPr>
+          <p:cNvPr id="4" name="Content Placeholder 2">
+            <a:extLst>
+              <a:ext uri="{FF2B5EF4-FFF2-40B4-BE49-F238E27FC236}">
+                <a16:creationId xmlns:a16="http://schemas.microsoft.com/office/drawing/2014/main" id="{EFA9EC71-1EC7-B9B8-B255-12AF27D8ED5D}"/>
+              </a:ext>
+            </a:extLst>
+          </p:cNvPr>
+          <p:cNvSpPr>
+            <a:spLocks noGrp="1"/>
+          </p:cNvSpPr>
+          <p:nvPr>
+            <p:ph idx="1"/>
+          </p:nvPr>
+        </p:nvSpPr>
+        <p:spPr>
+          <a:xfrm>
+            <a:off x="838199" y="1825625"/>
+            <a:ext cx="10809850" cy="4667250"/>
+          </a:xfrm>
+        </p:spPr>
+        <p:txBody>
+          <a:bodyPr>
+            <a:normAutofit/>
+          </a:bodyPr>
+          <a:lstStyle/>
+          <a:p>
+            <a:pPr marL="0" indent="0">
+              <a:buNone/>
+            </a:pPr>
+            <a:r>
+              <a:rPr lang="en-CH" sz="2200" b="1" dirty="0"/>
+              <a:t>RANDOM INITIALIZED TRANSFORMER</a:t>
+            </a:r>
+          </a:p>
+          <a:p>
+            <a:pPr marL="0" indent="0">
+              <a:buNone/>
+            </a:pPr>
+            <a:r>
+              <a:rPr lang="en-CH" sz="2200" dirty="0"/>
+              <a:t>	always predicts sol1</a:t>
+            </a:r>
+          </a:p>
+          <a:p>
+            <a:pPr marL="0" indent="0">
+              <a:buNone/>
+            </a:pPr>
+            <a:r>
+              <a:rPr lang="en-CH" sz="2200" dirty="0"/>
+              <a:t>	never learned anything</a:t>
+            </a:r>
+          </a:p>
+          <a:p>
+            <a:pPr marL="0" indent="0">
+              <a:buNone/>
+            </a:pPr>
+            <a:r>
+              <a:rPr lang="en-CH" sz="2200" dirty="0"/>
+              <a:t>	are 110B params too much to learn anything for about 15’000 data records?</a:t>
+            </a:r>
+          </a:p>
+          <a:p>
+            <a:pPr marL="0" indent="0">
+              <a:buNone/>
+            </a:pPr>
+            <a:endParaRPr lang="en-CH" sz="2200" dirty="0"/>
+          </a:p>
+          <a:p>
+            <a:pPr marL="0" indent="0">
+              <a:buNone/>
+            </a:pPr>
+            <a:r>
+              <a:rPr lang="en-CH" sz="2200" b="1" dirty="0"/>
+              <a:t>PRETRAINED TRANSFORMER</a:t>
+            </a:r>
+          </a:p>
+          <a:p>
+            <a:pPr marL="0" indent="0">
+              <a:buNone/>
+            </a:pPr>
+            <a:r>
+              <a:rPr lang="en-CH" sz="2200" dirty="0"/>
+              <a:t>	meaningful predictions </a:t>
+            </a:r>
+          </a:p>
+          <a:p>
+            <a:pPr marL="0" indent="0">
+              <a:buNone/>
+            </a:pPr>
+            <a:r>
+              <a:rPr lang="en-CH" sz="2200" dirty="0"/>
+              <a:t>	bad regularization </a:t>
+            </a:r>
+            <a:r>
+              <a:rPr lang="en-CH" sz="2200" b="1" dirty="0"/>
+              <a:t>	</a:t>
+            </a:r>
+          </a:p>
+          <a:p>
+            <a:pPr marL="0" indent="0">
+              <a:buNone/>
+            </a:pPr>
+            <a:r>
+              <a:rPr lang="en-CH" sz="2200" b="1" dirty="0"/>
+              <a:t>	</a:t>
+            </a:r>
+            <a:r>
+              <a:rPr lang="en-GB" sz="2200" dirty="0" err="1"/>
+              <a:t>OneCycleLR</a:t>
+            </a:r>
+            <a:r>
+              <a:rPr lang="en-GB" sz="2200" b="1" dirty="0"/>
+              <a:t> </a:t>
+            </a:r>
+            <a:r>
+              <a:rPr lang="en-GB" sz="2200" dirty="0"/>
+              <a:t>scheduler improved test set acc. by 0.056 </a:t>
+            </a:r>
+          </a:p>
+          <a:p>
+            <a:pPr marL="0" indent="0">
+              <a:buNone/>
+            </a:pPr>
+            <a:r>
+              <a:rPr lang="en-GB" sz="2200" dirty="0"/>
+              <a:t>	(pretrained weights are not destroyed)</a:t>
+            </a:r>
+            <a:endParaRPr lang="en-CH" sz="2200" b="1" dirty="0"/>
+          </a:p>
+        </p:txBody>
+      </p:sp>
+    </p:spTree>
+    <p:extLst>
+      <p:ext uri="{BB962C8B-B14F-4D97-AF65-F5344CB8AC3E}">
+        <p14:creationId xmlns:p14="http://schemas.microsoft.com/office/powerpoint/2010/main" val="1306507813"/>
+      </p:ext>
+    </p:extLst>
+  </p:cSld>
+  <p:clrMapOvr>
+    <a:masterClrMapping/>
+  </p:clrMapOvr>
+</p:sld>
+</file>
+
+<file path=ppt/slides/slide14.xml><?xml version="1.0" encoding="utf-8"?>
+<p:sld xmlns:a="http://schemas.openxmlformats.org/drawingml/2006/main" xmlns:r="http://schemas.openxmlformats.org/officeDocument/2006/relationships" xmlns:p="http://schemas.openxmlformats.org/presentationml/2006/main">
+  <p:cSld>
+    <p:spTree>
+      <p:nvGrpSpPr>
+        <p:cNvPr id="1" name=""/>
+        <p:cNvGrpSpPr/>
+        <p:nvPr/>
+      </p:nvGrpSpPr>
+      <p:grpSpPr>
+        <a:xfrm>
+          <a:off x="0" y="0"/>
+          <a:ext cx="0" cy="0"/>
+          <a:chOff x="0" y="0"/>
+          <a:chExt cx="0" cy="0"/>
+        </a:xfrm>
+      </p:grpSpPr>
+      <p:sp>
+        <p:nvSpPr>
+          <p:cNvPr id="2" name="Title 1">
+            <a:extLst>
+              <a:ext uri="{FF2B5EF4-FFF2-40B4-BE49-F238E27FC236}">
+                <a16:creationId xmlns:a16="http://schemas.microsoft.com/office/drawing/2014/main" id="{97E073E8-A468-A30B-7B45-E2E008616637}"/>
+              </a:ext>
+            </a:extLst>
+          </p:cNvPr>
+          <p:cNvSpPr>
+            <a:spLocks noGrp="1"/>
+          </p:cNvSpPr>
+          <p:nvPr>
+            <p:ph type="title"/>
+          </p:nvPr>
+        </p:nvSpPr>
+        <p:spPr/>
+        <p:txBody>
+          <a:bodyPr/>
+          <a:lstStyle/>
+          <a:p>
+            <a:r>
+              <a:rPr lang="en-CH" dirty="0"/>
+              <a:t>Interpretation</a:t>
+            </a:r>
+          </a:p>
+        </p:txBody>
+      </p:sp>
+      <p:sp>
+        <p:nvSpPr>
+          <p:cNvPr id="4" name="Content Placeholder 2">
+            <a:extLst>
+              <a:ext uri="{FF2B5EF4-FFF2-40B4-BE49-F238E27FC236}">
+                <a16:creationId xmlns:a16="http://schemas.microsoft.com/office/drawing/2014/main" id="{EFA9EC71-1EC7-B9B8-B255-12AF27D8ED5D}"/>
+              </a:ext>
+            </a:extLst>
+          </p:cNvPr>
+          <p:cNvSpPr>
+            <a:spLocks noGrp="1"/>
+          </p:cNvSpPr>
+          <p:nvPr>
+            <p:ph idx="1"/>
+          </p:nvPr>
+        </p:nvSpPr>
+        <p:spPr>
+          <a:xfrm>
+            <a:off x="838199" y="1825625"/>
+            <a:ext cx="10809850" cy="4667250"/>
+          </a:xfrm>
+        </p:spPr>
+        <p:txBody>
+          <a:bodyPr>
+            <a:normAutofit/>
+          </a:bodyPr>
+          <a:lstStyle/>
+          <a:p>
+            <a:pPr marL="0" indent="0">
+              <a:buNone/>
+            </a:pPr>
+            <a:r>
+              <a:rPr lang="en-CH" sz="2200" b="1" dirty="0"/>
+              <a:t>LLM</a:t>
+            </a:r>
+          </a:p>
+          <a:p>
+            <a:pPr marL="0" indent="0">
+              <a:buNone/>
+            </a:pPr>
+            <a:r>
+              <a:rPr lang="en-CH" sz="2200" dirty="0"/>
+              <a:t>	solid predictions</a:t>
+            </a:r>
+          </a:p>
+          <a:p>
+            <a:pPr marL="0" indent="0">
+              <a:buNone/>
+            </a:pPr>
+            <a:r>
+              <a:rPr lang="en-GB" sz="2200" dirty="0">
+                <a:solidFill>
+                  <a:srgbClr val="067D17"/>
+                </a:solidFill>
+                <a:effectLst/>
+              </a:rPr>
+              <a:t>	Qwen2.5-</a:t>
+            </a:r>
+            <a:r>
+              <a:rPr lang="en-GB" sz="2200" b="1" dirty="0">
+                <a:solidFill>
+                  <a:srgbClr val="067D17"/>
+                </a:solidFill>
+                <a:effectLst/>
+              </a:rPr>
+              <a:t>3B</a:t>
+            </a:r>
+            <a:r>
+              <a:rPr lang="en-GB" sz="2200" dirty="0">
+                <a:solidFill>
+                  <a:srgbClr val="067D17"/>
+                </a:solidFill>
+                <a:effectLst/>
+              </a:rPr>
+              <a:t>-Instruct </a:t>
+            </a:r>
+            <a:r>
+              <a:rPr lang="en-GB" sz="2200" dirty="0">
+                <a:effectLst/>
+              </a:rPr>
+              <a:t>outperformed</a:t>
+            </a:r>
+            <a:r>
+              <a:rPr lang="en-GB" sz="2200" dirty="0">
+                <a:solidFill>
+                  <a:srgbClr val="067D17"/>
+                </a:solidFill>
+                <a:effectLst/>
+              </a:rPr>
+              <a:t> Qwen2.5-</a:t>
+            </a:r>
+            <a:r>
+              <a:rPr lang="en-GB" sz="2200" b="1" dirty="0">
+                <a:solidFill>
+                  <a:srgbClr val="067D17"/>
+                </a:solidFill>
+                <a:effectLst/>
+              </a:rPr>
+              <a:t>1.5B</a:t>
+            </a:r>
+            <a:r>
+              <a:rPr lang="en-GB" sz="2200" dirty="0">
+                <a:solidFill>
+                  <a:srgbClr val="067D17"/>
+                </a:solidFill>
+                <a:effectLst/>
+              </a:rPr>
+              <a:t>-Instruct </a:t>
+            </a:r>
+          </a:p>
+          <a:p>
+            <a:pPr marL="0" indent="0">
+              <a:buNone/>
+            </a:pPr>
+            <a:r>
+              <a:rPr lang="en-GB" sz="2200" dirty="0">
+                <a:effectLst/>
+              </a:rPr>
+              <a:t>	(by 0.143 on the same prompt)</a:t>
+            </a:r>
+            <a:endParaRPr lang="en-CH" sz="2200" dirty="0"/>
+          </a:p>
+          <a:p>
+            <a:pPr marL="0" indent="0">
+              <a:buNone/>
+            </a:pPr>
+            <a:endParaRPr lang="en-CH" sz="2200" dirty="0"/>
+          </a:p>
+          <a:p>
+            <a:pPr marL="0" indent="0">
+              <a:buNone/>
+            </a:pPr>
+            <a:r>
+              <a:rPr lang="en-CH" sz="2200" b="1" dirty="0"/>
+              <a:t>KEY TAKEAWAY</a:t>
+            </a:r>
+          </a:p>
+          <a:p>
+            <a:pPr marL="0" indent="0">
+              <a:buNone/>
+            </a:pPr>
+            <a:r>
+              <a:rPr lang="en-CH" sz="2200" dirty="0"/>
+              <a:t>	models fail on </a:t>
+            </a:r>
+            <a:r>
+              <a:rPr lang="de-CH" sz="2200" dirty="0" err="1"/>
+              <a:t>near</a:t>
+            </a:r>
+            <a:r>
+              <a:rPr lang="de-CH" sz="2200" dirty="0"/>
+              <a:t> </a:t>
+            </a:r>
+            <a:r>
+              <a:rPr lang="de-CH" sz="2200" dirty="0" err="1"/>
+              <a:t>identical</a:t>
+            </a:r>
+            <a:r>
+              <a:rPr lang="de-CH" sz="2200" dirty="0"/>
+              <a:t> </a:t>
+            </a:r>
+            <a:r>
+              <a:rPr lang="de-CH" sz="2200" dirty="0" err="1"/>
+              <a:t>solutions</a:t>
+            </a:r>
+            <a:endParaRPr lang="de-CH" sz="2200" dirty="0"/>
+          </a:p>
+          <a:p>
+            <a:pPr marL="0" indent="0">
+              <a:buNone/>
+            </a:pPr>
+            <a:r>
+              <a:rPr lang="de-CH" sz="2200" b="1" dirty="0"/>
+              <a:t>	</a:t>
+            </a:r>
+            <a:r>
+              <a:rPr lang="de-CH" sz="2200" dirty="0" err="1"/>
+              <a:t>physical</a:t>
+            </a:r>
+            <a:r>
+              <a:rPr lang="de-CH" sz="2200" dirty="0"/>
+              <a:t> </a:t>
+            </a:r>
+            <a:r>
+              <a:rPr lang="de-CH" sz="2200" dirty="0" err="1"/>
+              <a:t>commonsense</a:t>
+            </a:r>
+            <a:r>
+              <a:rPr lang="de-CH" sz="2200" dirty="0"/>
+              <a:t> </a:t>
+            </a:r>
+            <a:r>
+              <a:rPr lang="de-CH" sz="2200" dirty="0" err="1"/>
+              <a:t>world</a:t>
+            </a:r>
+            <a:r>
+              <a:rPr lang="de-CH" sz="2200" dirty="0"/>
+              <a:t> </a:t>
+            </a:r>
+            <a:r>
+              <a:rPr lang="de-CH" sz="2200" dirty="0" err="1"/>
+              <a:t>knowledge</a:t>
+            </a:r>
+            <a:r>
+              <a:rPr lang="de-CH" sz="2200" dirty="0"/>
+              <a:t> in </a:t>
+            </a:r>
+            <a:r>
+              <a:rPr lang="de-CH" sz="2200" dirty="0" err="1"/>
+              <a:t>training</a:t>
+            </a:r>
+            <a:r>
+              <a:rPr lang="de-CH" sz="2200" dirty="0"/>
+              <a:t> </a:t>
+            </a:r>
+            <a:r>
+              <a:rPr lang="de-CH" sz="2200" dirty="0" err="1"/>
+              <a:t>data</a:t>
+            </a:r>
+            <a:r>
+              <a:rPr lang="de-CH" sz="2200" dirty="0"/>
+              <a:t> </a:t>
+            </a:r>
+            <a:r>
+              <a:rPr lang="de-CH" sz="2200" dirty="0" err="1"/>
+              <a:t>of</a:t>
+            </a:r>
+            <a:r>
+              <a:rPr lang="de-CH" sz="2200" dirty="0"/>
+              <a:t> LLM </a:t>
+            </a:r>
+            <a:r>
+              <a:rPr lang="de-CH" sz="2200" dirty="0" err="1"/>
+              <a:t>outperforms</a:t>
+            </a:r>
+            <a:r>
+              <a:rPr lang="de-CH" sz="2200" dirty="0"/>
+              <a:t> 	</a:t>
+            </a:r>
+            <a:r>
+              <a:rPr lang="de-CH" sz="2200" dirty="0" err="1"/>
+              <a:t>task</a:t>
+            </a:r>
+            <a:r>
+              <a:rPr lang="de-CH" sz="2200" dirty="0"/>
+              <a:t> </a:t>
+            </a:r>
+            <a:r>
+              <a:rPr lang="de-CH" sz="2200" dirty="0" err="1"/>
+              <a:t>specific</a:t>
+            </a:r>
+            <a:r>
+              <a:rPr lang="de-CH" sz="2200" dirty="0"/>
+              <a:t> </a:t>
+            </a:r>
+            <a:r>
+              <a:rPr lang="de-CH" sz="2200" dirty="0" err="1"/>
+              <a:t>fine</a:t>
+            </a:r>
+            <a:r>
+              <a:rPr lang="de-CH" sz="2200" dirty="0"/>
+              <a:t> </a:t>
+            </a:r>
+            <a:r>
+              <a:rPr lang="de-CH" sz="2200" dirty="0" err="1"/>
+              <a:t>tuning</a:t>
+            </a:r>
+            <a:endParaRPr lang="en-CH" sz="2200" b="1" dirty="0"/>
+          </a:p>
+        </p:txBody>
+      </p:sp>
+    </p:spTree>
+    <p:extLst>
+      <p:ext uri="{BB962C8B-B14F-4D97-AF65-F5344CB8AC3E}">
+        <p14:creationId xmlns:p14="http://schemas.microsoft.com/office/powerpoint/2010/main" val="4278970052"/>
+      </p:ext>
+    </p:extLst>
+  </p:cSld>
+  <p:clrMapOvr>
+    <a:masterClrMapping/>
+  </p:clrMapOvr>
+</p:sld>
+</file>
+
+<file path=ppt/slides/slide15.xml><?xml version="1.0" encoding="utf-8"?>
+<p:sld xmlns:a="http://schemas.openxmlformats.org/drawingml/2006/main" xmlns:r="http://schemas.openxmlformats.org/officeDocument/2006/relationships" xmlns:p="http://schemas.openxmlformats.org/presentationml/2006/main">
+  <p:cSld>
+    <p:spTree>
+      <p:nvGrpSpPr>
+        <p:cNvPr id="1" name=""/>
+        <p:cNvGrpSpPr/>
+        <p:nvPr/>
+      </p:nvGrpSpPr>
+      <p:grpSpPr>
+        <a:xfrm>
+          <a:off x="0" y="0"/>
+          <a:ext cx="0" cy="0"/>
+          <a:chOff x="0" y="0"/>
+          <a:chExt cx="0" cy="0"/>
+        </a:xfrm>
+      </p:grpSpPr>
+      <p:sp>
+        <p:nvSpPr>
+          <p:cNvPr id="2" name="Title 1">
+            <a:extLst>
+              <a:ext uri="{FF2B5EF4-FFF2-40B4-BE49-F238E27FC236}">
+                <a16:creationId xmlns:a16="http://schemas.microsoft.com/office/drawing/2014/main" id="{ED910561-C0D8-DFF0-0E68-D958DD557650}"/>
+              </a:ext>
+            </a:extLst>
+          </p:cNvPr>
+          <p:cNvSpPr>
+            <a:spLocks noGrp="1"/>
+          </p:cNvSpPr>
+          <p:nvPr>
+            <p:ph type="ctrTitle"/>
+          </p:nvPr>
+        </p:nvSpPr>
+        <p:spPr>
+          <a:xfrm>
+            <a:off x="790354" y="2235200"/>
+            <a:ext cx="9144000" cy="2387600"/>
+          </a:xfrm>
+        </p:spPr>
+        <p:txBody>
+          <a:bodyPr/>
+          <a:lstStyle/>
+          <a:p>
+            <a:pPr algn="l"/>
+            <a:r>
+              <a:rPr lang="en-CH" b="1" dirty="0"/>
+              <a:t>Thank You </a:t>
+            </a:r>
+            <a:r>
+              <a:rPr lang="en-CH" dirty="0"/>
+              <a:t>For Your Attention!</a:t>
+            </a:r>
+          </a:p>
+        </p:txBody>
+      </p:sp>
+    </p:spTree>
+    <p:extLst>
+      <p:ext uri="{BB962C8B-B14F-4D97-AF65-F5344CB8AC3E}">
+        <p14:creationId xmlns:p14="http://schemas.microsoft.com/office/powerpoint/2010/main" val="4242504431"/>
+      </p:ext>
+    </p:extLst>
+  </p:cSld>
+  <p:clrMapOvr>
+    <a:masterClrMapping/>
+  </p:clrMapOvr>
+</p:sld>
+</file>
+
+<file path=ppt/slides/slide16.xml><?xml version="1.0" encoding="utf-8"?>
+<p:sld xmlns:a="http://schemas.openxmlformats.org/drawingml/2006/main" xmlns:r="http://schemas.openxmlformats.org/officeDocument/2006/relationships" xmlns:p="http://schemas.openxmlformats.org/presentationml/2006/main">
+  <p:cSld>
+    <p:spTree>
+      <p:nvGrpSpPr>
+        <p:cNvPr id="1" name=""/>
+        <p:cNvGrpSpPr/>
+        <p:nvPr/>
+      </p:nvGrpSpPr>
+      <p:grpSpPr>
+        <a:xfrm>
+          <a:off x="0" y="0"/>
+          <a:ext cx="0" cy="0"/>
+          <a:chOff x="0" y="0"/>
+          <a:chExt cx="0" cy="0"/>
+        </a:xfrm>
+      </p:grpSpPr>
+      <p:sp>
+        <p:nvSpPr>
+          <p:cNvPr id="2" name="Title 1">
+            <a:extLst>
+              <a:ext uri="{FF2B5EF4-FFF2-40B4-BE49-F238E27FC236}">
+                <a16:creationId xmlns:a16="http://schemas.microsoft.com/office/drawing/2014/main" id="{ED910561-C0D8-DFF0-0E68-D958DD557650}"/>
+              </a:ext>
+            </a:extLst>
+          </p:cNvPr>
+          <p:cNvSpPr>
+            <a:spLocks noGrp="1"/>
+          </p:cNvSpPr>
+          <p:nvPr>
+            <p:ph type="ctrTitle"/>
+          </p:nvPr>
+        </p:nvSpPr>
+        <p:spPr>
+          <a:xfrm>
+            <a:off x="790354" y="2235200"/>
+            <a:ext cx="9144000" cy="2387600"/>
+          </a:xfrm>
+        </p:spPr>
+        <p:txBody>
+          <a:bodyPr/>
+          <a:lstStyle/>
+          <a:p>
+            <a:pPr algn="l"/>
+            <a:r>
+              <a:rPr lang="en-CH" dirty="0"/>
+              <a:t>Are There Any </a:t>
+            </a:r>
+            <a:r>
+              <a:rPr lang="en-CH" b="1" dirty="0"/>
+              <a:t>Questions</a:t>
+            </a:r>
+            <a:r>
+              <a:rPr lang="en-CH" dirty="0"/>
+              <a:t>?</a:t>
+            </a:r>
+          </a:p>
+        </p:txBody>
+      </p:sp>
+    </p:spTree>
+    <p:extLst>
+      <p:ext uri="{BB962C8B-B14F-4D97-AF65-F5344CB8AC3E}">
+        <p14:creationId xmlns:p14="http://schemas.microsoft.com/office/powerpoint/2010/main" val="1607646033"/>
       </p:ext>
     </p:extLst>
   </p:cSld>
@@ -3970,17 +5848,17 @@
           <a:p>
             <a:r>
               <a:rPr lang="en-CH" dirty="0"/>
-              <a:t>Input / Output Format</a:t>
-            </a:r>
-          </a:p>
-        </p:txBody>
-      </p:sp>
-      <p:sp>
-        <p:nvSpPr>
-          <p:cNvPr id="3" name="Content Placeholder 2">
-            <a:extLst>
-              <a:ext uri="{FF2B5EF4-FFF2-40B4-BE49-F238E27FC236}">
-                <a16:creationId xmlns:a16="http://schemas.microsoft.com/office/drawing/2014/main" id="{D89DBAB5-34EE-EEFE-506D-80D32626B75E}"/>
+              <a:t>Input / Output Format Transformers</a:t>
+            </a:r>
+          </a:p>
+        </p:txBody>
+      </p:sp>
+      <p:sp>
+        <p:nvSpPr>
+          <p:cNvPr id="4" name="Content Placeholder 2">
+            <a:extLst>
+              <a:ext uri="{FF2B5EF4-FFF2-40B4-BE49-F238E27FC236}">
+                <a16:creationId xmlns:a16="http://schemas.microsoft.com/office/drawing/2014/main" id="{D2FA5359-C197-0343-B96C-5BBE95AA653D}"/>
               </a:ext>
             </a:extLst>
           </p:cNvPr>
@@ -3991,19 +5869,144 @@
             <p:ph idx="1"/>
           </p:nvPr>
         </p:nvSpPr>
-        <p:spPr/>
-        <p:txBody>
-          <a:bodyPr/>
+        <p:spPr>
+          <a:xfrm>
+            <a:off x="838200" y="1825625"/>
+            <a:ext cx="5349240" cy="4351338"/>
+          </a:xfrm>
+        </p:spPr>
+        <p:txBody>
+          <a:bodyPr>
+            <a:normAutofit/>
+          </a:bodyPr>
           <a:lstStyle/>
           <a:p>
-            <a:endParaRPr lang="en-CH"/>
+            <a:pPr marL="0" indent="0">
+              <a:buNone/>
+            </a:pPr>
+            <a:r>
+              <a:rPr lang="en-CH" sz="2200" b="1" dirty="0"/>
+              <a:t>TOKENIZATION</a:t>
+            </a:r>
+          </a:p>
+          <a:p>
+            <a:pPr marL="0" indent="0">
+              <a:buNone/>
+            </a:pPr>
+            <a:r>
+              <a:rPr lang="en-CH" sz="2200" dirty="0"/>
+              <a:t>	</a:t>
+            </a:r>
+            <a:r>
+              <a:rPr lang="en-GB" sz="2200" dirty="0" err="1">
+                <a:solidFill>
+                  <a:srgbClr val="067D17"/>
+                </a:solidFill>
+                <a:effectLst/>
+              </a:rPr>
+              <a:t>bert</a:t>
+            </a:r>
+            <a:r>
+              <a:rPr lang="en-GB" sz="2200" dirty="0">
+                <a:solidFill>
+                  <a:srgbClr val="067D17"/>
+                </a:solidFill>
+                <a:effectLst/>
+              </a:rPr>
+              <a:t>-base-uncased</a:t>
+            </a:r>
+          </a:p>
+          <a:p>
+            <a:pPr marL="0" indent="0">
+              <a:buNone/>
+            </a:pPr>
+            <a:r>
+              <a:rPr lang="en-CH" sz="2200" dirty="0"/>
+              <a:t>	truncate at 126 (99th percentile)</a:t>
+            </a:r>
+          </a:p>
+          <a:p>
+            <a:pPr marL="0" indent="0">
+              <a:buNone/>
+            </a:pPr>
+            <a:r>
+              <a:rPr lang="en-CH" sz="2200" dirty="0"/>
+              <a:t>	(OOM with max input length - 512)</a:t>
+            </a:r>
+          </a:p>
+          <a:p>
+            <a:pPr marL="0" indent="0">
+              <a:buNone/>
+            </a:pPr>
+            <a:endParaRPr lang="en-CH" sz="2200" dirty="0"/>
+          </a:p>
+          <a:p>
+            <a:pPr marL="0" indent="0">
+              <a:buNone/>
+            </a:pPr>
+            <a:endParaRPr lang="en-CH" sz="2200" dirty="0"/>
+          </a:p>
+          <a:p>
+            <a:pPr marL="0" indent="0">
+              <a:buNone/>
+            </a:pPr>
+            <a:r>
+              <a:rPr lang="en-CH" sz="2200" b="1" dirty="0"/>
+              <a:t>TEXT EXAMPLE</a:t>
+            </a:r>
+          </a:p>
+        </p:txBody>
+      </p:sp>
+      <p:sp>
+        <p:nvSpPr>
+          <p:cNvPr id="5" name="TextBox 4">
+            <a:extLst>
+              <a:ext uri="{FF2B5EF4-FFF2-40B4-BE49-F238E27FC236}">
+                <a16:creationId xmlns:a16="http://schemas.microsoft.com/office/drawing/2014/main" id="{9374F0C7-CD48-4575-E956-689CE80D6E2B}"/>
+              </a:ext>
+            </a:extLst>
+          </p:cNvPr>
+          <p:cNvSpPr txBox="1"/>
+          <p:nvPr/>
+        </p:nvSpPr>
+        <p:spPr>
+          <a:xfrm>
+            <a:off x="1778000" y="4876800"/>
+            <a:ext cx="8636000" cy="769441"/>
+          </a:xfrm>
+          <a:prstGeom prst="rect">
+            <a:avLst/>
+          </a:prstGeom>
+          <a:noFill/>
+        </p:spPr>
+        <p:txBody>
+          <a:bodyPr wrap="square" rtlCol="0">
+            <a:spAutoFit/>
+          </a:bodyPr>
+          <a:lstStyle/>
+          <a:p>
+            <a:r>
+              <a:rPr lang="en-GB" sz="2200" dirty="0">
+                <a:solidFill>
+                  <a:srgbClr val="067D17"/>
+                </a:solidFill>
+                <a:effectLst/>
+              </a:rPr>
+              <a:t>['[CLS]', 'when', 'boiling', 'butter', ',', 'when', 'it', "'", 's', 'ready', ',', 'you', 'can', '[SEP]', 'pour', 'it', 'onto', 'a', 'plate', '[SEP]']</a:t>
+            </a:r>
+            <a:endParaRPr lang="en-GB" sz="2200" dirty="0">
+              <a:solidFill>
+                <a:srgbClr val="080808"/>
+              </a:solidFill>
+              <a:effectLst/>
+            </a:endParaRPr>
           </a:p>
         </p:txBody>
       </p:sp>
     </p:spTree>
     <p:extLst>
       <p:ext uri="{BB962C8B-B14F-4D97-AF65-F5344CB8AC3E}">
-        <p14:creationId xmlns:p14="http://schemas.microsoft.com/office/powerpoint/2010/main" val="3008471701"/>
+        <p14:creationId xmlns:p14="http://schemas.microsoft.com/office/powerpoint/2010/main" val="453374706"/>
       </p:ext>
     </p:extLst>
   </p:cSld>
@@ -4053,17 +6056,17 @@
           <a:p>
             <a:r>
               <a:rPr lang="en-CH" dirty="0"/>
-              <a:t>Network Architecture</a:t>
-            </a:r>
-          </a:p>
-        </p:txBody>
-      </p:sp>
-      <p:sp>
-        <p:nvSpPr>
-          <p:cNvPr id="3" name="Content Placeholder 2">
-            <a:extLst>
-              <a:ext uri="{FF2B5EF4-FFF2-40B4-BE49-F238E27FC236}">
-                <a16:creationId xmlns:a16="http://schemas.microsoft.com/office/drawing/2014/main" id="{D89DBAB5-34EE-EEFE-506D-80D32626B75E}"/>
+              <a:t>Input / Output Format Transformers</a:t>
+            </a:r>
+          </a:p>
+        </p:txBody>
+      </p:sp>
+      <p:sp>
+        <p:nvSpPr>
+          <p:cNvPr id="4" name="Content Placeholder 2">
+            <a:extLst>
+              <a:ext uri="{FF2B5EF4-FFF2-40B4-BE49-F238E27FC236}">
+                <a16:creationId xmlns:a16="http://schemas.microsoft.com/office/drawing/2014/main" id="{D2FA5359-C197-0343-B96C-5BBE95AA653D}"/>
               </a:ext>
             </a:extLst>
           </p:cNvPr>
@@ -4074,19 +6077,161 @@
             <p:ph idx="1"/>
           </p:nvPr>
         </p:nvSpPr>
-        <p:spPr/>
-        <p:txBody>
-          <a:bodyPr/>
+        <p:spPr>
+          <a:xfrm>
+            <a:off x="838200" y="1825625"/>
+            <a:ext cx="7969624" cy="4351338"/>
+          </a:xfrm>
+        </p:spPr>
+        <p:txBody>
+          <a:bodyPr>
+            <a:normAutofit/>
+          </a:bodyPr>
           <a:lstStyle/>
           <a:p>
-            <a:endParaRPr lang="en-CH"/>
+            <a:pPr marL="0" indent="0">
+              <a:buNone/>
+            </a:pPr>
+            <a:r>
+              <a:rPr lang="en-CH" sz="2200" b="1" dirty="0"/>
+              <a:t>TOKENIZATION</a:t>
+            </a:r>
+          </a:p>
+          <a:p>
+            <a:pPr marL="0" indent="0">
+              <a:buNone/>
+            </a:pPr>
+            <a:r>
+              <a:rPr lang="en-CH" sz="2200" b="1" dirty="0"/>
+              <a:t>	</a:t>
+            </a:r>
+            <a:r>
+              <a:rPr lang="en-CH" sz="2200" dirty="0"/>
+              <a:t>label					</a:t>
+            </a:r>
+            <a:r>
+              <a:rPr lang="en-CH" sz="2200" i="1" dirty="0"/>
+              <a:t>0 or 1</a:t>
+            </a:r>
+          </a:p>
+          <a:p>
+            <a:pPr marL="0" indent="0">
+              <a:buNone/>
+            </a:pPr>
+            <a:endParaRPr lang="en-CH" sz="2200" b="1" dirty="0"/>
+          </a:p>
+          <a:p>
+            <a:pPr marL="0" indent="0">
+              <a:buNone/>
+            </a:pPr>
+            <a:r>
+              <a:rPr lang="en-CH" sz="2200" b="1" dirty="0"/>
+              <a:t>	</a:t>
+            </a:r>
+            <a:r>
+              <a:rPr lang="en-GB" sz="2200" dirty="0"/>
+              <a:t>input1_attention_mask		</a:t>
+            </a:r>
+            <a:r>
+              <a:rPr lang="en-GB" sz="2200" i="1" dirty="0"/>
+              <a:t>always 1</a:t>
+            </a:r>
+          </a:p>
+          <a:p>
+            <a:pPr marL="0" indent="0">
+              <a:buNone/>
+            </a:pPr>
+            <a:r>
+              <a:rPr lang="en-GB" sz="2200" dirty="0"/>
+              <a:t>	input1_input_ids			</a:t>
+            </a:r>
+            <a:r>
+              <a:rPr lang="en-GB" sz="2200" i="1" dirty="0"/>
+              <a:t>token ids</a:t>
+            </a:r>
+          </a:p>
+          <a:p>
+            <a:pPr marL="0" indent="0">
+              <a:buNone/>
+            </a:pPr>
+            <a:r>
+              <a:rPr lang="en-GB" sz="2200" dirty="0"/>
+              <a:t>	input1_token_type_ids			</a:t>
+            </a:r>
+            <a:r>
+              <a:rPr lang="en-GB" sz="2200" i="1" dirty="0"/>
+              <a:t>goal 0 / sol 1</a:t>
+            </a:r>
+          </a:p>
+          <a:p>
+            <a:pPr marL="0" indent="0">
+              <a:buNone/>
+            </a:pPr>
+            <a:endParaRPr lang="en-GB" sz="2200" dirty="0"/>
+          </a:p>
+          <a:p>
+            <a:pPr marL="0" indent="0">
+              <a:buNone/>
+            </a:pPr>
+            <a:r>
+              <a:rPr lang="en-GB" sz="2200" dirty="0"/>
+              <a:t>	input2_attention_mask		</a:t>
+            </a:r>
+            <a:r>
+              <a:rPr lang="en-GB" sz="2200" i="1" dirty="0"/>
+              <a:t>always 1</a:t>
+            </a:r>
+          </a:p>
+          <a:p>
+            <a:pPr marL="0" indent="0">
+              <a:buNone/>
+            </a:pPr>
+            <a:r>
+              <a:rPr lang="en-GB" sz="2200" dirty="0"/>
+              <a:t>	input2_input_ids			</a:t>
+            </a:r>
+            <a:r>
+              <a:rPr lang="en-GB" sz="2200" i="1" dirty="0"/>
+              <a:t>token ids</a:t>
+            </a:r>
+          </a:p>
+          <a:p>
+            <a:pPr marL="0" indent="0">
+              <a:buNone/>
+            </a:pPr>
+            <a:r>
+              <a:rPr lang="en-GB" sz="2200" dirty="0"/>
+              <a:t>	input2_token_type_ids			</a:t>
+            </a:r>
+            <a:r>
+              <a:rPr lang="en-GB" sz="2200" i="1" dirty="0"/>
+              <a:t>goal 0 / sol 1</a:t>
+            </a:r>
+          </a:p>
+          <a:p>
+            <a:pPr marL="0" indent="0">
+              <a:buNone/>
+            </a:pPr>
+            <a:endParaRPr lang="en-GB" sz="2200" dirty="0"/>
+          </a:p>
+          <a:p>
+            <a:pPr marL="0" indent="0">
+              <a:buNone/>
+            </a:pPr>
+            <a:endParaRPr lang="en-CH" sz="2200" dirty="0"/>
+          </a:p>
+          <a:p>
+            <a:pPr marL="0" indent="0">
+              <a:buNone/>
+            </a:pPr>
+            <a:endParaRPr lang="en-CH" sz="2200" dirty="0"/>
           </a:p>
         </p:txBody>
       </p:sp>
     </p:spTree>
     <p:extLst>
       <p:ext uri="{BB962C8B-B14F-4D97-AF65-F5344CB8AC3E}">
-        <p14:creationId xmlns:p14="http://schemas.microsoft.com/office/powerpoint/2010/main" val="524450196"/>
+        <p14:creationId xmlns:p14="http://schemas.microsoft.com/office/powerpoint/2010/main" val="3008471701"/>
       </p:ext>
     </p:extLst>
   </p:cSld>
@@ -4136,17 +6281,17 @@
           <a:p>
             <a:r>
               <a:rPr lang="en-CH" dirty="0"/>
-              <a:t>Experiments</a:t>
-            </a:r>
-          </a:p>
-        </p:txBody>
-      </p:sp>
-      <p:sp>
-        <p:nvSpPr>
-          <p:cNvPr id="3" name="Content Placeholder 2">
-            <a:extLst>
-              <a:ext uri="{FF2B5EF4-FFF2-40B4-BE49-F238E27FC236}">
-                <a16:creationId xmlns:a16="http://schemas.microsoft.com/office/drawing/2014/main" id="{D89DBAB5-34EE-EEFE-506D-80D32626B75E}"/>
+              <a:t>Input / Output Format Transformers</a:t>
+            </a:r>
+          </a:p>
+        </p:txBody>
+      </p:sp>
+      <p:sp>
+        <p:nvSpPr>
+          <p:cNvPr id="4" name="Content Placeholder 2">
+            <a:extLst>
+              <a:ext uri="{FF2B5EF4-FFF2-40B4-BE49-F238E27FC236}">
+                <a16:creationId xmlns:a16="http://schemas.microsoft.com/office/drawing/2014/main" id="{D2FA5359-C197-0343-B96C-5BBE95AA653D}"/>
               </a:ext>
             </a:extLst>
           </p:cNvPr>
@@ -4157,19 +6302,160 @@
             <p:ph idx="1"/>
           </p:nvPr>
         </p:nvSpPr>
-        <p:spPr/>
-        <p:txBody>
-          <a:bodyPr/>
+        <p:spPr>
+          <a:xfrm>
+            <a:off x="838200" y="1825625"/>
+            <a:ext cx="7969624" cy="4351338"/>
+          </a:xfrm>
+        </p:spPr>
+        <p:txBody>
+          <a:bodyPr>
+            <a:normAutofit/>
+          </a:bodyPr>
           <a:lstStyle/>
           <a:p>
-            <a:endParaRPr lang="en-CH"/>
+            <a:pPr marL="0" indent="0">
+              <a:buNone/>
+            </a:pPr>
+            <a:r>
+              <a:rPr lang="en-CH" sz="2200" b="1" dirty="0"/>
+              <a:t>DATA LOADER</a:t>
+            </a:r>
+          </a:p>
+          <a:p>
+            <a:pPr marL="0" indent="0">
+              <a:buNone/>
+            </a:pPr>
+            <a:r>
+              <a:rPr lang="en-CH" sz="2200" b="1" dirty="0"/>
+              <a:t>	</a:t>
+            </a:r>
+            <a:r>
+              <a:rPr lang="en-GB" sz="1600" dirty="0">
+                <a:solidFill>
+                  <a:srgbClr val="080808"/>
+                </a:solidFill>
+                <a:effectLst/>
+              </a:rPr>
+              <a:t> </a:t>
+            </a:r>
+            <a:r>
+              <a:rPr lang="en-GB" sz="2200" dirty="0">
+                <a:solidFill>
+                  <a:srgbClr val="080808"/>
+                </a:solidFill>
+                <a:effectLst/>
+              </a:rPr>
+              <a:t>BATCH_SIZE = </a:t>
+            </a:r>
+            <a:r>
+              <a:rPr lang="en-GB" sz="2200" dirty="0">
+                <a:solidFill>
+                  <a:srgbClr val="1750EB"/>
+                </a:solidFill>
+                <a:effectLst/>
+              </a:rPr>
+              <a:t>32</a:t>
+            </a:r>
+            <a:endParaRPr lang="en-GB" sz="2200" dirty="0">
+              <a:solidFill>
+                <a:srgbClr val="080808"/>
+              </a:solidFill>
+              <a:effectLst/>
+            </a:endParaRPr>
+          </a:p>
+          <a:p>
+            <a:pPr marL="0" indent="0">
+              <a:buNone/>
+            </a:pPr>
+            <a:r>
+              <a:rPr lang="en-CH" sz="2200" b="1" dirty="0"/>
+              <a:t>	</a:t>
+            </a:r>
+          </a:p>
+          <a:p>
+            <a:pPr marL="0" indent="0">
+              <a:buNone/>
+            </a:pPr>
+            <a:r>
+              <a:rPr lang="en-CH" sz="2200" b="1" dirty="0"/>
+              <a:t>	</a:t>
+            </a:r>
+            <a:r>
+              <a:rPr lang="en-CH" sz="2200" dirty="0"/>
+              <a:t>pad to longest input sequence in batch</a:t>
+            </a:r>
+          </a:p>
+          <a:p>
+            <a:pPr marL="0" indent="0">
+              <a:buNone/>
+            </a:pPr>
+            <a:r>
+              <a:rPr lang="en-CH" sz="2200" b="1" dirty="0"/>
+              <a:t>	</a:t>
+            </a:r>
+            <a:r>
+              <a:rPr lang="en-CH" sz="2200" dirty="0"/>
+              <a:t>create tensor for each input</a:t>
+            </a:r>
+            <a:endParaRPr lang="en-CH" sz="2200" b="1" dirty="0"/>
+          </a:p>
+          <a:p>
+            <a:pPr marL="0" indent="0">
+              <a:buNone/>
+            </a:pPr>
+            <a:r>
+              <a:rPr lang="en-CH" sz="2200" b="1" dirty="0"/>
+              <a:t>	</a:t>
+            </a:r>
+            <a:endParaRPr lang="en-CH" sz="2200" dirty="0"/>
+          </a:p>
+          <a:p>
+            <a:pPr marL="0" indent="0">
+              <a:buNone/>
+            </a:pPr>
+            <a:r>
+              <a:rPr lang="en-CH" sz="2200" b="1" dirty="0"/>
+              <a:t>FINAL INPUT FORMAT</a:t>
+            </a:r>
+          </a:p>
+          <a:p>
+            <a:pPr marL="0" indent="0">
+              <a:buNone/>
+            </a:pPr>
+            <a:r>
+              <a:rPr lang="en-CH" sz="2200" b="1" dirty="0"/>
+              <a:t>	</a:t>
+            </a:r>
+            <a:r>
+              <a:rPr lang="en-CH" sz="2200" dirty="0"/>
+              <a:t>encode inputs into [CLS] vector (768 dim)</a:t>
+            </a:r>
+          </a:p>
+          <a:p>
+            <a:pPr marL="0" indent="0">
+              <a:buNone/>
+            </a:pPr>
+            <a:r>
+              <a:rPr lang="en-CH" sz="2200" dirty="0"/>
+              <a:t>	concatenate CLS1 &amp; CLS2 into (1536 dim)</a:t>
+            </a:r>
+          </a:p>
+          <a:p>
+            <a:pPr marL="0" indent="0">
+              <a:buNone/>
+            </a:pPr>
+            <a:r>
+              <a:rPr lang="en-CH" sz="2200" b="1" dirty="0"/>
+              <a:t>	</a:t>
+            </a:r>
           </a:p>
         </p:txBody>
       </p:sp>
     </p:spTree>
     <p:extLst>
       <p:ext uri="{BB962C8B-B14F-4D97-AF65-F5344CB8AC3E}">
-        <p14:creationId xmlns:p14="http://schemas.microsoft.com/office/powerpoint/2010/main" val="2976245617"/>
+        <p14:creationId xmlns:p14="http://schemas.microsoft.com/office/powerpoint/2010/main" val="3440011565"/>
       </p:ext>
     </p:extLst>
   </p:cSld>
@@ -4219,342 +6505,462 @@
           <a:p>
             <a:r>
               <a:rPr lang="en-CH" dirty="0"/>
-              <a:t>Results</a:t>
-            </a:r>
-          </a:p>
-        </p:txBody>
-      </p:sp>
-      <p:graphicFrame>
-        <p:nvGraphicFramePr>
-          <p:cNvPr id="4" name="Content Placeholder 3">
-            <a:extLst>
-              <a:ext uri="{FF2B5EF4-FFF2-40B4-BE49-F238E27FC236}">
-                <a16:creationId xmlns:a16="http://schemas.microsoft.com/office/drawing/2014/main" id="{7FED4360-A5C2-82D2-160F-48D286277966}"/>
-              </a:ext>
-            </a:extLst>
-          </p:cNvPr>
-          <p:cNvGraphicFramePr>
-            <a:graphicFrameLocks noGrp="1"/>
-          </p:cNvGraphicFramePr>
+              <a:t>Input / Output Format Transformers</a:t>
+            </a:r>
+          </a:p>
+        </p:txBody>
+      </p:sp>
+      <p:sp>
+        <p:nvSpPr>
+          <p:cNvPr id="4" name="Content Placeholder 2">
+            <a:extLst>
+              <a:ext uri="{FF2B5EF4-FFF2-40B4-BE49-F238E27FC236}">
+                <a16:creationId xmlns:a16="http://schemas.microsoft.com/office/drawing/2014/main" id="{D2FA5359-C197-0343-B96C-5BBE95AA653D}"/>
+              </a:ext>
+            </a:extLst>
+          </p:cNvPr>
+          <p:cNvSpPr>
+            <a:spLocks noGrp="1"/>
+          </p:cNvSpPr>
           <p:nvPr>
             <p:ph idx="1"/>
-            <p:extLst>
-              <p:ext uri="{D42A27DB-BD31-4B8C-83A1-F6EECF244321}">
-                <p14:modId xmlns:p14="http://schemas.microsoft.com/office/powerpoint/2010/main" val="465899192"/>
-              </p:ext>
-            </p:extLst>
-          </p:nvPr>
-        </p:nvGraphicFramePr>
-        <p:xfrm>
-          <a:off x="838200" y="2108200"/>
-          <a:ext cx="10515600" cy="2839720"/>
-        </p:xfrm>
-        <a:graphic>
-          <a:graphicData uri="http://schemas.openxmlformats.org/drawingml/2006/table">
-            <a:tbl>
-              <a:tblPr firstRow="1" bandRow="1">
-                <a:tableStyleId>{9D7B26C5-4107-4FEC-AEDC-1716B250A1EF}</a:tableStyleId>
-              </a:tblPr>
-              <a:tblGrid>
-                <a:gridCol w="2628900">
-                  <a:extLst>
-                    <a:ext uri="{9D8B030D-6E8A-4147-A177-3AD203B41FA5}">
-                      <a16:colId xmlns:a16="http://schemas.microsoft.com/office/drawing/2014/main" val="953994096"/>
-                    </a:ext>
-                  </a:extLst>
-                </a:gridCol>
-                <a:gridCol w="2628900">
-                  <a:extLst>
-                    <a:ext uri="{9D8B030D-6E8A-4147-A177-3AD203B41FA5}">
-                      <a16:colId xmlns:a16="http://schemas.microsoft.com/office/drawing/2014/main" val="2341483827"/>
-                    </a:ext>
-                  </a:extLst>
-                </a:gridCol>
-                <a:gridCol w="2804160">
-                  <a:extLst>
-                    <a:ext uri="{9D8B030D-6E8A-4147-A177-3AD203B41FA5}">
-                      <a16:colId xmlns:a16="http://schemas.microsoft.com/office/drawing/2014/main" val="2574548658"/>
-                    </a:ext>
-                  </a:extLst>
-                </a:gridCol>
-                <a:gridCol w="2453640">
-                  <a:extLst>
-                    <a:ext uri="{9D8B030D-6E8A-4147-A177-3AD203B41FA5}">
-                      <a16:colId xmlns:a16="http://schemas.microsoft.com/office/drawing/2014/main" val="1423803622"/>
-                    </a:ext>
-                  </a:extLst>
-                </a:gridCol>
-              </a:tblGrid>
-              <a:tr h="370840">
-                <a:tc>
-                  <a:txBody>
-                    <a:bodyPr/>
-                    <a:lstStyle/>
-                    <a:p>
-                      <a:r>
-                        <a:rPr lang="en-CH" dirty="0"/>
-                        <a:t>Model</a:t>
-                      </a:r>
-                    </a:p>
-                  </a:txBody>
-                  <a:tcPr/>
-                </a:tc>
-                <a:tc>
-                  <a:txBody>
-                    <a:bodyPr/>
-                    <a:lstStyle/>
-                    <a:p>
-                      <a:r>
-                        <a:rPr lang="en-CH" dirty="0"/>
-                        <a:t>Training Set Accuracy</a:t>
-                      </a:r>
-                    </a:p>
-                  </a:txBody>
-                  <a:tcPr/>
-                </a:tc>
-                <a:tc>
-                  <a:txBody>
-                    <a:bodyPr/>
-                    <a:lstStyle/>
-                    <a:p>
-                      <a:r>
-                        <a:rPr lang="en-CH" dirty="0"/>
-                        <a:t>Validation Set Accuracy</a:t>
-                      </a:r>
-                    </a:p>
-                  </a:txBody>
-                  <a:tcPr/>
-                </a:tc>
-                <a:tc>
-                  <a:txBody>
-                    <a:bodyPr/>
-                    <a:lstStyle/>
-                    <a:p>
-                      <a:r>
-                        <a:rPr lang="en-CH" dirty="0"/>
-                        <a:t>Test Set Accuracy</a:t>
-                      </a:r>
-                    </a:p>
-                  </a:txBody>
-                  <a:tcPr/>
-                </a:tc>
-                <a:extLst>
-                  <a:ext uri="{0D108BD9-81ED-4DB2-BD59-A6C34878D82A}">
-                    <a16:rowId xmlns:a16="http://schemas.microsoft.com/office/drawing/2014/main" val="2936785088"/>
-                  </a:ext>
-                </a:extLst>
-              </a:tr>
-              <a:tr h="370840">
-                <a:tc>
-                  <a:txBody>
-                    <a:bodyPr/>
-                    <a:lstStyle/>
-                    <a:p>
-                      <a:r>
-                        <a:rPr lang="en-CH" dirty="0"/>
-                        <a:t>Random Initialized BERT</a:t>
-                      </a:r>
-                    </a:p>
-                    <a:p>
-                      <a:endParaRPr lang="en-CH" dirty="0"/>
-                    </a:p>
-                  </a:txBody>
-                  <a:tcPr/>
-                </a:tc>
-                <a:tc>
-                  <a:txBody>
-                    <a:bodyPr/>
-                    <a:lstStyle/>
-                    <a:p>
-                      <a:r>
-                        <a:rPr lang="en-CH" dirty="0"/>
-                        <a:t>0.504</a:t>
-                      </a:r>
-                    </a:p>
-                  </a:txBody>
-                  <a:tcPr/>
-                </a:tc>
-                <a:tc>
-                  <a:txBody>
-                    <a:bodyPr/>
-                    <a:lstStyle/>
-                    <a:p>
-                      <a:r>
-                        <a:rPr lang="en-CH" dirty="0"/>
-                        <a:t>0.517</a:t>
-                      </a:r>
-                    </a:p>
-                  </a:txBody>
-                  <a:tcPr/>
-                </a:tc>
-                <a:tc>
-                  <a:txBody>
-                    <a:bodyPr/>
-                    <a:lstStyle/>
-                    <a:p>
-                      <a:r>
-                        <a:rPr lang="en-CH" dirty="0"/>
-                        <a:t>0.496</a:t>
-                      </a:r>
-                    </a:p>
-                  </a:txBody>
-                  <a:tcPr/>
-                </a:tc>
-                <a:extLst>
-                  <a:ext uri="{0D108BD9-81ED-4DB2-BD59-A6C34878D82A}">
-                    <a16:rowId xmlns:a16="http://schemas.microsoft.com/office/drawing/2014/main" val="563072786"/>
-                  </a:ext>
-                </a:extLst>
-              </a:tr>
-              <a:tr h="370840">
-                <a:tc>
-                  <a:txBody>
-                    <a:bodyPr/>
-                    <a:lstStyle/>
-                    <a:p>
-                      <a:r>
-                        <a:rPr lang="en-CH" dirty="0"/>
-                        <a:t>Pretrained BERT </a:t>
-                      </a:r>
-                    </a:p>
-                    <a:p>
-                      <a:r>
-                        <a:rPr lang="en-CH" dirty="0"/>
-                        <a:t>(bert-base-uncased)</a:t>
-                      </a:r>
-                    </a:p>
-                    <a:p>
-                      <a:endParaRPr lang="en-CH" dirty="0"/>
-                    </a:p>
-                  </a:txBody>
-                  <a:tcPr/>
-                </a:tc>
-                <a:tc>
-                  <a:txBody>
-                    <a:bodyPr/>
-                    <a:lstStyle/>
-                    <a:p>
-                      <a:r>
-                        <a:rPr lang="en-CH" dirty="0"/>
-                        <a:t>0.956</a:t>
-                      </a:r>
-                    </a:p>
-                  </a:txBody>
-                  <a:tcPr/>
-                </a:tc>
-                <a:tc>
-                  <a:txBody>
-                    <a:bodyPr/>
-                    <a:lstStyle/>
-                    <a:p>
-                      <a:r>
-                        <a:rPr lang="en-CH" dirty="0"/>
-                        <a:t>0.668</a:t>
-                      </a:r>
-                    </a:p>
-                  </a:txBody>
-                  <a:tcPr/>
-                </a:tc>
-                <a:tc>
-                  <a:txBody>
-                    <a:bodyPr/>
-                    <a:lstStyle/>
-                    <a:p>
-                      <a:r>
-                        <a:rPr lang="en-CH" dirty="0"/>
-                        <a:t>0.656</a:t>
-                      </a:r>
-                    </a:p>
-                  </a:txBody>
-                  <a:tcPr/>
-                </a:tc>
-                <a:extLst>
-                  <a:ext uri="{0D108BD9-81ED-4DB2-BD59-A6C34878D82A}">
-                    <a16:rowId xmlns:a16="http://schemas.microsoft.com/office/drawing/2014/main" val="2433388229"/>
-                  </a:ext>
-                </a:extLst>
-              </a:tr>
-              <a:tr h="370840">
-                <a:tc>
-                  <a:txBody>
-                    <a:bodyPr/>
-                    <a:lstStyle/>
-                    <a:p>
-                      <a:r>
-                        <a:rPr lang="en-CH" dirty="0"/>
-                        <a:t>LLM </a:t>
-                      </a:r>
-                    </a:p>
-                    <a:p>
-                      <a:r>
-                        <a:rPr lang="en-GB" dirty="0">
-                          <a:solidFill>
-                            <a:srgbClr val="080808"/>
-                          </a:solidFill>
-                          <a:effectLst/>
-                        </a:rPr>
-                        <a:t>(Qwen2.5-3B-Instruct)</a:t>
-                      </a:r>
-                    </a:p>
-                    <a:p>
-                      <a:endParaRPr lang="en-CH" dirty="0"/>
-                    </a:p>
-                  </a:txBody>
-                  <a:tcPr/>
-                </a:tc>
-                <a:tc>
-                  <a:txBody>
-                    <a:bodyPr/>
-                    <a:lstStyle/>
-                    <a:p>
-                      <a:r>
-                        <a:rPr lang="en-CH" dirty="0"/>
-                        <a:t>-</a:t>
-                      </a:r>
-                    </a:p>
-                  </a:txBody>
-                  <a:tcPr/>
-                </a:tc>
-                <a:tc>
-                  <a:txBody>
-                    <a:bodyPr/>
-                    <a:lstStyle/>
-                    <a:p>
-                      <a:r>
-                        <a:rPr lang="en-CH" dirty="0"/>
-                        <a:t>-</a:t>
-                      </a:r>
-                    </a:p>
-                  </a:txBody>
-                  <a:tcPr/>
-                </a:tc>
-                <a:tc>
-                  <a:txBody>
-                    <a:bodyPr/>
-                    <a:lstStyle/>
-                    <a:p>
-                      <a:r>
-                        <a:rPr lang="en-CH" dirty="0"/>
-                        <a:t>0.753</a:t>
-                      </a:r>
-                    </a:p>
-                  </a:txBody>
-                  <a:tcPr/>
-                </a:tc>
-                <a:extLst>
-                  <a:ext uri="{0D108BD9-81ED-4DB2-BD59-A6C34878D82A}">
-                    <a16:rowId xmlns:a16="http://schemas.microsoft.com/office/drawing/2014/main" val="550076995"/>
-                  </a:ext>
-                </a:extLst>
-              </a:tr>
-            </a:tbl>
-          </a:graphicData>
-        </a:graphic>
-      </p:graphicFrame>
+          </p:nvPr>
+        </p:nvSpPr>
+        <p:spPr>
+          <a:xfrm>
+            <a:off x="838199" y="1825625"/>
+            <a:ext cx="9744635" cy="4351338"/>
+          </a:xfrm>
+        </p:spPr>
+        <p:txBody>
+          <a:bodyPr>
+            <a:normAutofit/>
+          </a:bodyPr>
+          <a:lstStyle/>
+          <a:p>
+            <a:pPr marL="0" indent="0">
+              <a:buNone/>
+            </a:pPr>
+            <a:r>
+              <a:rPr lang="en-CH" sz="2200" b="1" dirty="0"/>
+              <a:t>OUTPUT</a:t>
+            </a:r>
+          </a:p>
+          <a:p>
+            <a:pPr marL="0" indent="0">
+              <a:buNone/>
+            </a:pPr>
+            <a:r>
+              <a:rPr lang="en-CH" sz="2200" b="1" dirty="0"/>
+              <a:t>	</a:t>
+            </a:r>
+            <a:r>
+              <a:rPr lang="en-GB" sz="1600" dirty="0">
+                <a:solidFill>
+                  <a:srgbClr val="080808"/>
+                </a:solidFill>
+                <a:effectLst/>
+              </a:rPr>
+              <a:t> </a:t>
+            </a:r>
+            <a:r>
+              <a:rPr lang="de-CH" sz="2200" dirty="0">
+                <a:solidFill>
+                  <a:srgbClr val="080808"/>
+                </a:solidFill>
+                <a:effectLst/>
+              </a:rPr>
+              <a:t>2 </a:t>
+            </a:r>
+            <a:r>
+              <a:rPr lang="de-CH" sz="2200" dirty="0" err="1">
+                <a:solidFill>
+                  <a:srgbClr val="080808"/>
+                </a:solidFill>
+                <a:effectLst/>
+              </a:rPr>
+              <a:t>logits</a:t>
+            </a:r>
+            <a:endParaRPr lang="de-CH" sz="2200" dirty="0">
+              <a:solidFill>
+                <a:srgbClr val="080808"/>
+              </a:solidFill>
+              <a:effectLst/>
+            </a:endParaRPr>
+          </a:p>
+          <a:p>
+            <a:pPr marL="0" indent="0">
+              <a:buNone/>
+            </a:pPr>
+            <a:r>
+              <a:rPr lang="de-CH" sz="2200" b="1" dirty="0">
+                <a:solidFill>
+                  <a:srgbClr val="080808"/>
+                </a:solidFill>
+              </a:rPr>
+              <a:t>	</a:t>
+            </a:r>
+            <a:r>
+              <a:rPr lang="de-CH" sz="2200" dirty="0" err="1">
+                <a:solidFill>
+                  <a:srgbClr val="080808"/>
+                </a:solidFill>
+              </a:rPr>
+              <a:t>argmax</a:t>
+            </a:r>
+            <a:r>
+              <a:rPr lang="de-CH" sz="2200" dirty="0">
+                <a:solidFill>
+                  <a:srgbClr val="080808"/>
+                </a:solidFill>
+              </a:rPr>
+              <a:t> </a:t>
+            </a:r>
+            <a:r>
+              <a:rPr lang="de-CH" sz="2200" dirty="0" err="1">
+                <a:solidFill>
+                  <a:srgbClr val="080808"/>
+                </a:solidFill>
+              </a:rPr>
+              <a:t>of</a:t>
+            </a:r>
+            <a:r>
+              <a:rPr lang="de-CH" sz="2200" dirty="0">
+                <a:solidFill>
+                  <a:srgbClr val="080808"/>
+                </a:solidFill>
+              </a:rPr>
+              <a:t> </a:t>
+            </a:r>
+            <a:r>
+              <a:rPr lang="de-CH" sz="2200" dirty="0" err="1">
+                <a:solidFill>
+                  <a:srgbClr val="080808"/>
+                </a:solidFill>
+              </a:rPr>
+              <a:t>those</a:t>
+            </a:r>
+            <a:r>
+              <a:rPr lang="de-CH" sz="2200" dirty="0">
+                <a:solidFill>
+                  <a:srgbClr val="080808"/>
+                </a:solidFill>
+              </a:rPr>
+              <a:t> </a:t>
+            </a:r>
+            <a:r>
+              <a:rPr lang="de-CH" sz="2200" dirty="0" err="1">
+                <a:solidFill>
+                  <a:srgbClr val="080808"/>
+                </a:solidFill>
+              </a:rPr>
+              <a:t>logits</a:t>
+            </a:r>
+            <a:r>
+              <a:rPr lang="de-CH" sz="2200" dirty="0">
+                <a:solidFill>
+                  <a:srgbClr val="080808"/>
+                </a:solidFill>
+              </a:rPr>
+              <a:t> 		</a:t>
+            </a:r>
+            <a:r>
+              <a:rPr lang="de-CH" sz="2200" dirty="0" err="1">
+                <a:solidFill>
+                  <a:srgbClr val="080808"/>
+                </a:solidFill>
+              </a:rPr>
+              <a:t>predicted</a:t>
+            </a:r>
+            <a:r>
+              <a:rPr lang="de-CH" sz="2200" dirty="0">
+                <a:solidFill>
+                  <a:srgbClr val="080808"/>
+                </a:solidFill>
+              </a:rPr>
+              <a:t> </a:t>
+            </a:r>
+            <a:r>
+              <a:rPr lang="de-CH" sz="2200" dirty="0" err="1">
+                <a:solidFill>
+                  <a:srgbClr val="080808"/>
+                </a:solidFill>
+              </a:rPr>
+              <a:t>label</a:t>
+            </a:r>
+            <a:r>
+              <a:rPr lang="de-CH" sz="2200" dirty="0">
+                <a:solidFill>
+                  <a:srgbClr val="080808"/>
+                </a:solidFill>
+              </a:rPr>
+              <a:t>		</a:t>
+            </a:r>
+            <a:r>
+              <a:rPr lang="de-CH" sz="2200" i="1" dirty="0">
+                <a:solidFill>
+                  <a:srgbClr val="080808"/>
+                </a:solidFill>
+              </a:rPr>
+              <a:t>0 / 1</a:t>
+            </a:r>
+          </a:p>
+          <a:p>
+            <a:pPr marL="0" indent="0">
+              <a:buNone/>
+            </a:pPr>
+            <a:endParaRPr lang="de-CH" sz="2200" i="1" dirty="0">
+              <a:solidFill>
+                <a:srgbClr val="080808"/>
+              </a:solidFill>
+            </a:endParaRPr>
+          </a:p>
+          <a:p>
+            <a:pPr marL="0" indent="0">
+              <a:buNone/>
+            </a:pPr>
+            <a:r>
+              <a:rPr lang="de-CH" sz="2200" i="1" dirty="0">
+                <a:solidFill>
+                  <a:srgbClr val="080808"/>
+                </a:solidFill>
+              </a:rPr>
+              <a:t>	</a:t>
+            </a:r>
+            <a:r>
+              <a:rPr lang="de-CH" sz="2200" dirty="0">
+                <a:solidFill>
+                  <a:srgbClr val="080808"/>
+                </a:solidFill>
+              </a:rPr>
+              <a:t>SOL1 </a:t>
+            </a:r>
+            <a:r>
+              <a:rPr lang="de-CH" sz="2200" dirty="0" err="1">
+                <a:solidFill>
+                  <a:srgbClr val="080808"/>
+                </a:solidFill>
+              </a:rPr>
+              <a:t>is</a:t>
+            </a:r>
+            <a:r>
+              <a:rPr lang="de-CH" sz="2200" dirty="0">
+                <a:solidFill>
+                  <a:srgbClr val="080808"/>
+                </a:solidFill>
+              </a:rPr>
+              <a:t> </a:t>
+            </a:r>
+            <a:r>
+              <a:rPr lang="de-CH" sz="2200" dirty="0" err="1">
+                <a:solidFill>
+                  <a:srgbClr val="080808"/>
+                </a:solidFill>
+              </a:rPr>
+              <a:t>correct</a:t>
+            </a:r>
+            <a:r>
+              <a:rPr lang="de-CH" sz="2200" dirty="0">
+                <a:solidFill>
+                  <a:srgbClr val="080808"/>
+                </a:solidFill>
+              </a:rPr>
+              <a:t> </a:t>
+            </a:r>
+            <a:r>
+              <a:rPr lang="de-CH" sz="2200" dirty="0" err="1">
+                <a:solidFill>
+                  <a:srgbClr val="080808"/>
+                </a:solidFill>
+              </a:rPr>
+              <a:t>if</a:t>
+            </a:r>
+            <a:r>
+              <a:rPr lang="de-CH" sz="2200" dirty="0">
+                <a:solidFill>
+                  <a:srgbClr val="080808"/>
+                </a:solidFill>
+              </a:rPr>
+              <a:t> </a:t>
+            </a:r>
+            <a:r>
+              <a:rPr lang="de-CH" sz="2200" dirty="0" err="1">
+                <a:solidFill>
+                  <a:srgbClr val="080808"/>
+                </a:solidFill>
+              </a:rPr>
+              <a:t>predicted</a:t>
+            </a:r>
+            <a:r>
+              <a:rPr lang="de-CH" sz="2200" dirty="0">
+                <a:solidFill>
+                  <a:srgbClr val="080808"/>
+                </a:solidFill>
+              </a:rPr>
+              <a:t> </a:t>
+            </a:r>
+            <a:r>
+              <a:rPr lang="de-CH" sz="2200" dirty="0" err="1">
+                <a:solidFill>
+                  <a:srgbClr val="080808"/>
+                </a:solidFill>
+              </a:rPr>
+              <a:t>label</a:t>
+            </a:r>
+            <a:r>
+              <a:rPr lang="de-CH" sz="2200" dirty="0">
+                <a:solidFill>
+                  <a:srgbClr val="080808"/>
+                </a:solidFill>
+              </a:rPr>
+              <a:t> = 0 </a:t>
+            </a:r>
+          </a:p>
+          <a:p>
+            <a:pPr marL="0" indent="0">
+              <a:buNone/>
+            </a:pPr>
+            <a:r>
+              <a:rPr lang="de-CH" sz="2200" dirty="0">
+                <a:solidFill>
+                  <a:srgbClr val="080808"/>
+                </a:solidFill>
+              </a:rPr>
+              <a:t>	SOL2 </a:t>
+            </a:r>
+            <a:r>
+              <a:rPr lang="de-CH" sz="2200" dirty="0" err="1">
+                <a:solidFill>
+                  <a:srgbClr val="080808"/>
+                </a:solidFill>
+              </a:rPr>
+              <a:t>is</a:t>
+            </a:r>
+            <a:r>
+              <a:rPr lang="de-CH" sz="2200" dirty="0">
+                <a:solidFill>
+                  <a:srgbClr val="080808"/>
+                </a:solidFill>
+              </a:rPr>
+              <a:t> </a:t>
+            </a:r>
+            <a:r>
+              <a:rPr lang="de-CH" sz="2200" dirty="0" err="1">
+                <a:solidFill>
+                  <a:srgbClr val="080808"/>
+                </a:solidFill>
+              </a:rPr>
+              <a:t>correct</a:t>
+            </a:r>
+            <a:r>
+              <a:rPr lang="de-CH" sz="2200" dirty="0">
+                <a:solidFill>
+                  <a:srgbClr val="080808"/>
+                </a:solidFill>
+              </a:rPr>
+              <a:t> </a:t>
+            </a:r>
+            <a:r>
+              <a:rPr lang="de-CH" sz="2200" dirty="0" err="1">
+                <a:solidFill>
+                  <a:srgbClr val="080808"/>
+                </a:solidFill>
+              </a:rPr>
+              <a:t>if</a:t>
+            </a:r>
+            <a:r>
+              <a:rPr lang="de-CH" sz="2200" dirty="0">
+                <a:solidFill>
+                  <a:srgbClr val="080808"/>
+                </a:solidFill>
+              </a:rPr>
+              <a:t> </a:t>
+            </a:r>
+            <a:r>
+              <a:rPr lang="de-CH" sz="2200" dirty="0" err="1">
+                <a:solidFill>
+                  <a:srgbClr val="080808"/>
+                </a:solidFill>
+              </a:rPr>
+              <a:t>predicted</a:t>
+            </a:r>
+            <a:r>
+              <a:rPr lang="de-CH" sz="2200" dirty="0">
+                <a:solidFill>
+                  <a:srgbClr val="080808"/>
+                </a:solidFill>
+              </a:rPr>
+              <a:t> </a:t>
+            </a:r>
+            <a:r>
+              <a:rPr lang="de-CH" sz="2200" dirty="0" err="1">
+                <a:solidFill>
+                  <a:srgbClr val="080808"/>
+                </a:solidFill>
+              </a:rPr>
+              <a:t>label</a:t>
+            </a:r>
+            <a:r>
+              <a:rPr lang="de-CH" sz="2200" dirty="0">
+                <a:solidFill>
+                  <a:srgbClr val="080808"/>
+                </a:solidFill>
+              </a:rPr>
+              <a:t> = 1	</a:t>
+            </a:r>
+            <a:r>
+              <a:rPr lang="en-CH" sz="2200" b="1" dirty="0"/>
+              <a:t>	</a:t>
+            </a:r>
+          </a:p>
+        </p:txBody>
+      </p:sp>
+      <p:cxnSp>
+        <p:nvCxnSpPr>
+          <p:cNvPr id="5" name="Straight Arrow Connector 4">
+            <a:extLst>
+              <a:ext uri="{FF2B5EF4-FFF2-40B4-BE49-F238E27FC236}">
+                <a16:creationId xmlns:a16="http://schemas.microsoft.com/office/drawing/2014/main" id="{4D7E0EB5-3BFB-4BC9-3441-FEEE4C7422A8}"/>
+              </a:ext>
+            </a:extLst>
+          </p:cNvPr>
+          <p:cNvCxnSpPr/>
+          <p:nvPr/>
+        </p:nvCxnSpPr>
+        <p:spPr>
+          <a:xfrm>
+            <a:off x="4814047" y="2891117"/>
+            <a:ext cx="363071" cy="0"/>
+          </a:xfrm>
+          <a:prstGeom prst="straightConnector1">
+            <a:avLst/>
+          </a:prstGeom>
+          <a:ln>
+            <a:solidFill>
+              <a:schemeClr val="tx1"/>
+            </a:solidFill>
+            <a:tailEnd type="triangle"/>
+          </a:ln>
+        </p:spPr>
+        <p:style>
+          <a:lnRef idx="2">
+            <a:schemeClr val="accent1"/>
+          </a:lnRef>
+          <a:fillRef idx="0">
+            <a:schemeClr val="accent1"/>
+          </a:fillRef>
+          <a:effectRef idx="1">
+            <a:schemeClr val="accent1"/>
+          </a:effectRef>
+          <a:fontRef idx="minor">
+            <a:schemeClr val="tx1"/>
+          </a:fontRef>
+        </p:style>
+      </p:cxnSp>
     </p:spTree>
     <p:extLst>
       <p:ext uri="{BB962C8B-B14F-4D97-AF65-F5344CB8AC3E}">
-        <p14:creationId xmlns:p14="http://schemas.microsoft.com/office/powerpoint/2010/main" val="2279130297"/>
+        <p14:creationId xmlns:p14="http://schemas.microsoft.com/office/powerpoint/2010/main" val="1095067011"/>
       </p:ext>
     </p:extLst>
   </p:cSld>
@@ -4604,17 +7010,17 @@
           <a:p>
             <a:r>
               <a:rPr lang="en-CH" dirty="0"/>
-              <a:t>Interpretation</a:t>
-            </a:r>
-          </a:p>
-        </p:txBody>
-      </p:sp>
-      <p:sp>
-        <p:nvSpPr>
-          <p:cNvPr id="3" name="Content Placeholder 2">
-            <a:extLst>
-              <a:ext uri="{FF2B5EF4-FFF2-40B4-BE49-F238E27FC236}">
-                <a16:creationId xmlns:a16="http://schemas.microsoft.com/office/drawing/2014/main" id="{D89DBAB5-34EE-EEFE-506D-80D32626B75E}"/>
+              <a:t>Input / Output Format LLM</a:t>
+            </a:r>
+          </a:p>
+        </p:txBody>
+      </p:sp>
+      <p:sp>
+        <p:nvSpPr>
+          <p:cNvPr id="4" name="Content Placeholder 2">
+            <a:extLst>
+              <a:ext uri="{FF2B5EF4-FFF2-40B4-BE49-F238E27FC236}">
+                <a16:creationId xmlns:a16="http://schemas.microsoft.com/office/drawing/2014/main" id="{D2FA5359-C197-0343-B96C-5BBE95AA653D}"/>
               </a:ext>
             </a:extLst>
           </p:cNvPr>
@@ -4625,19 +7031,258 @@
             <p:ph idx="1"/>
           </p:nvPr>
         </p:nvSpPr>
-        <p:spPr/>
-        <p:txBody>
-          <a:bodyPr/>
+        <p:spPr>
+          <a:xfrm>
+            <a:off x="838199" y="1825625"/>
+            <a:ext cx="6659881" cy="4351338"/>
+          </a:xfrm>
+        </p:spPr>
+        <p:txBody>
+          <a:bodyPr>
+            <a:normAutofit/>
+          </a:bodyPr>
           <a:lstStyle/>
           <a:p>
-            <a:endParaRPr lang="en-CH"/>
-          </a:p>
-        </p:txBody>
-      </p:sp>
+            <a:pPr marL="0" indent="0">
+              <a:buNone/>
+            </a:pPr>
+            <a:r>
+              <a:rPr lang="en-CH" sz="2200" b="1" dirty="0"/>
+              <a:t>PROMPTS</a:t>
+            </a:r>
+          </a:p>
+          <a:p>
+            <a:pPr marL="0" indent="0">
+              <a:buNone/>
+            </a:pPr>
+            <a:r>
+              <a:rPr lang="en-CH" sz="2200" b="1" dirty="0"/>
+              <a:t>	</a:t>
+            </a:r>
+            <a:r>
+              <a:rPr lang="en-CH" sz="2200" dirty="0"/>
+              <a:t>system prompt – assign role</a:t>
+            </a:r>
+          </a:p>
+          <a:p>
+            <a:pPr marL="0" indent="0">
+              <a:buNone/>
+            </a:pPr>
+            <a:r>
+              <a:rPr lang="en-CH" sz="2200" b="1" dirty="0"/>
+              <a:t>	</a:t>
+            </a:r>
+            <a:r>
+              <a:rPr lang="en-CH" sz="2200" dirty="0"/>
+              <a:t>user prompt – including goal, sol1 and sol2</a:t>
+            </a:r>
+          </a:p>
+          <a:p>
+            <a:pPr marL="0" indent="0">
+              <a:buNone/>
+            </a:pPr>
+            <a:endParaRPr lang="en-CH" sz="2200" b="1" dirty="0"/>
+          </a:p>
+          <a:p>
+            <a:pPr marL="0" indent="0">
+              <a:buNone/>
+            </a:pPr>
+            <a:r>
+              <a:rPr lang="en-CH" sz="2200" b="1" dirty="0"/>
+              <a:t>TOKENIZATION</a:t>
+            </a:r>
+          </a:p>
+          <a:p>
+            <a:pPr marL="0" indent="0">
+              <a:buNone/>
+            </a:pPr>
+            <a:r>
+              <a:rPr lang="en-CH" sz="2200" b="1" dirty="0"/>
+              <a:t>	</a:t>
+            </a:r>
+            <a:r>
+              <a:rPr lang="en-GB" sz="2200" dirty="0">
+                <a:solidFill>
+                  <a:srgbClr val="067D17"/>
+                </a:solidFill>
+                <a:effectLst/>
+              </a:rPr>
+              <a:t>Qwen2.5-3B-Instruct</a:t>
+            </a:r>
+          </a:p>
+          <a:p>
+            <a:pPr marL="0" indent="0">
+              <a:buNone/>
+            </a:pPr>
+            <a:r>
+              <a:rPr lang="en-GB" sz="2200" dirty="0">
+                <a:solidFill>
+                  <a:srgbClr val="067D17"/>
+                </a:solidFill>
+              </a:rPr>
+              <a:t>	</a:t>
+            </a:r>
+            <a:r>
+              <a:rPr lang="en-GB" sz="2200" dirty="0" err="1"/>
+              <a:t>apply_chat_template</a:t>
+            </a:r>
+            <a:r>
+              <a:rPr lang="en-GB" sz="2200" dirty="0"/>
+              <a:t> </a:t>
+            </a:r>
+            <a:endParaRPr lang="en-GB" sz="2200" dirty="0">
+              <a:solidFill>
+                <a:srgbClr val="080808"/>
+              </a:solidFill>
+              <a:effectLst/>
+            </a:endParaRPr>
+          </a:p>
+          <a:p>
+            <a:pPr marL="0" indent="0">
+              <a:buNone/>
+            </a:pPr>
+            <a:endParaRPr lang="en-CH" sz="2200" b="1" dirty="0"/>
+          </a:p>
+          <a:p>
+            <a:pPr marL="0" indent="0">
+              <a:buNone/>
+            </a:pPr>
+            <a:r>
+              <a:rPr lang="en-CH" sz="2200" b="1" dirty="0"/>
+              <a:t>	</a:t>
+            </a:r>
+            <a:r>
+              <a:rPr lang="en-CH" sz="2200" dirty="0"/>
+              <a:t>input_ids</a:t>
+            </a:r>
+          </a:p>
+          <a:p>
+            <a:pPr marL="0" indent="0">
+              <a:buNone/>
+            </a:pPr>
+            <a:r>
+              <a:rPr lang="en-CH" sz="2200" b="1" dirty="0"/>
+              <a:t>	</a:t>
+            </a:r>
+            <a:r>
+              <a:rPr lang="en-CH" sz="2200" dirty="0"/>
+              <a:t>attention_mask</a:t>
+            </a:r>
+          </a:p>
+        </p:txBody>
+      </p:sp>
+      <p:sp>
+        <p:nvSpPr>
+          <p:cNvPr id="3" name="TextBox 2">
+            <a:extLst>
+              <a:ext uri="{FF2B5EF4-FFF2-40B4-BE49-F238E27FC236}">
+                <a16:creationId xmlns:a16="http://schemas.microsoft.com/office/drawing/2014/main" id="{D14120E3-8265-1D9E-80BF-E203F7E1C160}"/>
+              </a:ext>
+            </a:extLst>
+          </p:cNvPr>
+          <p:cNvSpPr txBox="1"/>
+          <p:nvPr/>
+        </p:nvSpPr>
+        <p:spPr>
+          <a:xfrm>
+            <a:off x="6091106" y="3763632"/>
+            <a:ext cx="5257800" cy="1631216"/>
+          </a:xfrm>
+          <a:prstGeom prst="rect">
+            <a:avLst/>
+          </a:prstGeom>
+          <a:noFill/>
+        </p:spPr>
+        <p:txBody>
+          <a:bodyPr wrap="square" rtlCol="0">
+            <a:spAutoFit/>
+          </a:bodyPr>
+          <a:lstStyle/>
+          <a:p>
+            <a:r>
+              <a:rPr lang="en-GB" sz="2000" b="1" dirty="0"/>
+              <a:t>&lt;|system|&gt; </a:t>
+            </a:r>
+            <a:br>
+              <a:rPr lang="en-GB" sz="2000" dirty="0"/>
+            </a:br>
+            <a:r>
+              <a:rPr lang="en-GB" sz="2000" i="1" dirty="0"/>
+              <a:t>system prompt</a:t>
+            </a:r>
+            <a:br>
+              <a:rPr lang="en-GB" sz="2000" dirty="0">
+                <a:effectLst/>
+              </a:rPr>
+            </a:br>
+            <a:r>
+              <a:rPr lang="en-GB" sz="2000" b="1" dirty="0"/>
+              <a:t> &lt;|user|&gt; </a:t>
+            </a:r>
+            <a:br>
+              <a:rPr lang="en-GB" sz="2000" dirty="0"/>
+            </a:br>
+            <a:r>
+              <a:rPr lang="en-CH" sz="2000" i="1" dirty="0"/>
+              <a:t>user prompt – including goal, sol1 and sol2</a:t>
+            </a:r>
+            <a:br>
+              <a:rPr lang="en-GB" sz="2000" dirty="0"/>
+            </a:br>
+            <a:r>
+              <a:rPr lang="en-GB" sz="2000" b="1" dirty="0"/>
+              <a:t>&lt;|assistant|&gt;</a:t>
+            </a:r>
+            <a:endParaRPr lang="en-CH" sz="2000" b="1" dirty="0"/>
+          </a:p>
+        </p:txBody>
+      </p:sp>
+      <p:cxnSp>
+        <p:nvCxnSpPr>
+          <p:cNvPr id="6" name="Straight Arrow Connector 5">
+            <a:extLst>
+              <a:ext uri="{FF2B5EF4-FFF2-40B4-BE49-F238E27FC236}">
+                <a16:creationId xmlns:a16="http://schemas.microsoft.com/office/drawing/2014/main" id="{456F21D1-26E4-D3E3-194C-6E4BF2315F95}"/>
+              </a:ext>
+            </a:extLst>
+          </p:cNvPr>
+          <p:cNvCxnSpPr/>
+          <p:nvPr/>
+        </p:nvCxnSpPr>
+        <p:spPr>
+          <a:xfrm>
+            <a:off x="4926588" y="4579240"/>
+            <a:ext cx="363071" cy="0"/>
+          </a:xfrm>
+          <a:prstGeom prst="straightConnector1">
+            <a:avLst/>
+          </a:prstGeom>
+          <a:ln>
+            <a:solidFill>
+              <a:schemeClr val="tx1"/>
+            </a:solidFill>
+            <a:tailEnd type="triangle"/>
+          </a:ln>
+        </p:spPr>
+        <p:style>
+          <a:lnRef idx="2">
+            <a:schemeClr val="accent1"/>
+          </a:lnRef>
+          <a:fillRef idx="0">
+            <a:schemeClr val="accent1"/>
+          </a:fillRef>
+          <a:effectRef idx="1">
+            <a:schemeClr val="accent1"/>
+          </a:effectRef>
+          <a:fontRef idx="minor">
+            <a:schemeClr val="tx1"/>
+          </a:fontRef>
+        </p:style>
+      </p:cxnSp>
     </p:spTree>
     <p:extLst>
       <p:ext uri="{BB962C8B-B14F-4D97-AF65-F5344CB8AC3E}">
-        <p14:creationId xmlns:p14="http://schemas.microsoft.com/office/powerpoint/2010/main" val="2456630817"/>
+        <p14:creationId xmlns:p14="http://schemas.microsoft.com/office/powerpoint/2010/main" val="3440093373"/>
       </p:ext>
     </p:extLst>
   </p:cSld>
@@ -4669,35 +7314,125 @@
           <p:cNvPr id="2" name="Title 1">
             <a:extLst>
               <a:ext uri="{FF2B5EF4-FFF2-40B4-BE49-F238E27FC236}">
-                <a16:creationId xmlns:a16="http://schemas.microsoft.com/office/drawing/2014/main" id="{ED910561-C0D8-DFF0-0E68-D958DD557650}"/>
-              </a:ext>
-            </a:extLst>
-          </p:cNvPr>
-          <p:cNvSpPr>
-            <a:spLocks noGrp="1"/>
-          </p:cNvSpPr>
-          <p:nvPr>
-            <p:ph type="ctrTitle"/>
+                <a16:creationId xmlns:a16="http://schemas.microsoft.com/office/drawing/2014/main" id="{97E073E8-A468-A30B-7B45-E2E008616637}"/>
+              </a:ext>
+            </a:extLst>
+          </p:cNvPr>
+          <p:cNvSpPr>
+            <a:spLocks noGrp="1"/>
+          </p:cNvSpPr>
+          <p:nvPr>
+            <p:ph type="title"/>
+          </p:nvPr>
+        </p:nvSpPr>
+        <p:spPr/>
+        <p:txBody>
+          <a:bodyPr/>
+          <a:lstStyle/>
+          <a:p>
+            <a:r>
+              <a:rPr lang="en-CH" dirty="0"/>
+              <a:t>Input / Output Format LLM</a:t>
+            </a:r>
+          </a:p>
+        </p:txBody>
+      </p:sp>
+      <p:sp>
+        <p:nvSpPr>
+          <p:cNvPr id="4" name="Content Placeholder 2">
+            <a:extLst>
+              <a:ext uri="{FF2B5EF4-FFF2-40B4-BE49-F238E27FC236}">
+                <a16:creationId xmlns:a16="http://schemas.microsoft.com/office/drawing/2014/main" id="{D2FA5359-C197-0343-B96C-5BBE95AA653D}"/>
+              </a:ext>
+            </a:extLst>
+          </p:cNvPr>
+          <p:cNvSpPr>
+            <a:spLocks noGrp="1"/>
+          </p:cNvSpPr>
+          <p:nvPr>
+            <p:ph idx="1"/>
           </p:nvPr>
         </p:nvSpPr>
         <p:spPr>
           <a:xfrm>
-            <a:off x="790354" y="2235200"/>
-            <a:ext cx="9144000" cy="2387600"/>
+            <a:off x="838199" y="1825625"/>
+            <a:ext cx="10809850" cy="4351338"/>
           </a:xfrm>
         </p:spPr>
         <p:txBody>
-          <a:bodyPr/>
+          <a:bodyPr>
+            <a:normAutofit/>
+          </a:bodyPr>
           <a:lstStyle/>
           <a:p>
-            <a:pPr algn="l"/>
-            <a:r>
-              <a:rPr lang="en-CH" b="1" dirty="0"/>
-              <a:t>Thank You </a:t>
-            </a:r>
-            <a:r>
-              <a:rPr lang="en-CH" dirty="0"/>
-              <a:t>For Your Attention!</a:t>
+            <a:pPr marL="0" indent="0">
+              <a:buNone/>
+            </a:pPr>
+            <a:r>
+              <a:rPr lang="en-CH" sz="2200" b="1" dirty="0"/>
+              <a:t>OUTPUT</a:t>
+            </a:r>
+          </a:p>
+          <a:p>
+            <a:pPr marL="0" indent="0">
+              <a:buNone/>
+            </a:pPr>
+            <a:r>
+              <a:rPr lang="en-CH" sz="2200" b="1" dirty="0"/>
+              <a:t>	</a:t>
+            </a:r>
+            <a:r>
+              <a:rPr lang="en-CH" sz="2200" dirty="0"/>
+              <a:t>answer is concatenated with input		</a:t>
+            </a:r>
+            <a:r>
+              <a:rPr lang="en-GB" sz="2200" i="1" dirty="0"/>
+              <a:t>[... input tokens ..., 32, 198]</a:t>
+            </a:r>
+            <a:endParaRPr lang="en-CH" sz="2200" i="1" dirty="0"/>
+          </a:p>
+          <a:p>
+            <a:pPr marL="0" indent="0">
+              <a:buNone/>
+            </a:pPr>
+            <a:r>
+              <a:rPr lang="en-CH" sz="2200" dirty="0"/>
+              <a:t>	split answer to output				</a:t>
+            </a:r>
+            <a:r>
+              <a:rPr lang="en-CH" sz="2200" i="1" dirty="0"/>
+              <a:t>[32, 198]</a:t>
+            </a:r>
+          </a:p>
+          <a:p>
+            <a:pPr marL="0" indent="0">
+              <a:buNone/>
+            </a:pPr>
+            <a:r>
+              <a:rPr lang="en-CH" sz="2200" dirty="0"/>
+              <a:t>	decode						</a:t>
+            </a:r>
+            <a:r>
+              <a:rPr lang="en-GB" sz="2200" i="1" dirty="0" err="1"/>
+              <a:t>tokenizer.decode</a:t>
+            </a:r>
+            <a:r>
+              <a:rPr lang="en-GB" sz="2200" i="1" dirty="0"/>
+              <a:t>([32, 198]) → "A"</a:t>
+            </a:r>
+            <a:endParaRPr lang="en-CH" sz="2200" i="1" dirty="0"/>
+          </a:p>
+          <a:p>
+            <a:pPr marL="0" indent="0">
+              <a:buNone/>
+            </a:pPr>
+            <a:r>
+              <a:rPr lang="en-CH" sz="2200" b="1" dirty="0"/>
+              <a:t>	</a:t>
+            </a:r>
+            <a:r>
+              <a:rPr lang="en-CH" sz="2200" dirty="0"/>
+              <a:t>parse into predicted label 			A = 0 / B = 1 / default = -1</a:t>
             </a:r>
           </a:p>
         </p:txBody>
@@ -4705,7 +7440,7 @@
     </p:spTree>
     <p:extLst>
       <p:ext uri="{BB962C8B-B14F-4D97-AF65-F5344CB8AC3E}">
-        <p14:creationId xmlns:p14="http://schemas.microsoft.com/office/powerpoint/2010/main" val="4242504431"/>
+        <p14:creationId xmlns:p14="http://schemas.microsoft.com/office/powerpoint/2010/main" val="2313643915"/>
       </p:ext>
     </p:extLst>
   </p:cSld>
@@ -4732,44 +7467,120 @@
           <a:chExt cx="0" cy="0"/>
         </a:xfrm>
       </p:grpSpPr>
-      <p:sp>
-        <p:nvSpPr>
-          <p:cNvPr id="2" name="Title 1">
-            <a:extLst>
-              <a:ext uri="{FF2B5EF4-FFF2-40B4-BE49-F238E27FC236}">
-                <a16:creationId xmlns:a16="http://schemas.microsoft.com/office/drawing/2014/main" id="{ED910561-C0D8-DFF0-0E68-D958DD557650}"/>
-              </a:ext>
-            </a:extLst>
-          </p:cNvPr>
-          <p:cNvSpPr>
-            <a:spLocks noGrp="1"/>
-          </p:cNvSpPr>
-          <p:nvPr>
-            <p:ph type="ctrTitle"/>
-          </p:nvPr>
-        </p:nvSpPr>
+      <p:pic>
+        <p:nvPicPr>
+          <p:cNvPr id="3" name="Graphic 2">
+            <a:extLst>
+              <a:ext uri="{FF2B5EF4-FFF2-40B4-BE49-F238E27FC236}">
+                <a16:creationId xmlns:a16="http://schemas.microsoft.com/office/drawing/2014/main" id="{851724D9-E648-F2D9-3F0A-C645C692A734}"/>
+              </a:ext>
+            </a:extLst>
+          </p:cNvPr>
+          <p:cNvPicPr>
+            <a:picLocks noChangeAspect="1"/>
+          </p:cNvPicPr>
+          <p:nvPr/>
+        </p:nvPicPr>
+        <p:blipFill>
+          <a:blip r:embed="rId2">
+            <a:extLst>
+              <a:ext uri="{96DAC541-7B7A-43D3-8B79-37D633B846F1}">
+                <asvg:svgBlip xmlns:asvg="http://schemas.microsoft.com/office/drawing/2016/SVG/main" r:embed="rId3"/>
+              </a:ext>
+            </a:extLst>
+          </a:blip>
+          <a:stretch>
+            <a:fillRect/>
+          </a:stretch>
+        </p:blipFill>
         <p:spPr>
           <a:xfrm>
-            <a:off x="790354" y="2235200"/>
-            <a:ext cx="9144000" cy="2387600"/>
+            <a:off x="4078817" y="-96028"/>
+            <a:ext cx="8265583" cy="7050056"/>
+          </a:xfrm>
+          <a:prstGeom prst="rect">
+            <a:avLst/>
+          </a:prstGeom>
+        </p:spPr>
+      </p:pic>
+      <p:sp>
+        <p:nvSpPr>
+          <p:cNvPr id="5" name="Title 1">
+            <a:extLst>
+              <a:ext uri="{FF2B5EF4-FFF2-40B4-BE49-F238E27FC236}">
+                <a16:creationId xmlns:a16="http://schemas.microsoft.com/office/drawing/2014/main" id="{3DCD6375-9358-E18F-EB23-8F38BDA1BA54}"/>
+              </a:ext>
+            </a:extLst>
+          </p:cNvPr>
+          <p:cNvSpPr>
+            <a:spLocks noGrp="1"/>
+          </p:cNvSpPr>
+          <p:nvPr>
+            <p:ph type="title"/>
+          </p:nvPr>
+        </p:nvSpPr>
+        <p:spPr>
+          <a:xfrm>
+            <a:off x="838200" y="365124"/>
+            <a:ext cx="3663462" cy="2575023"/>
           </a:xfrm>
         </p:spPr>
         <p:txBody>
           <a:bodyPr/>
           <a:lstStyle/>
           <a:p>
-            <a:pPr algn="l"/>
             <a:r>
               <a:rPr lang="en-CH" dirty="0"/>
-              <a:t>Are There Any </a:t>
-            </a:r>
-            <a:r>
-              <a:rPr lang="en-CH" b="1" dirty="0"/>
-              <a:t>Questions</a:t>
-            </a:r>
-            <a:r>
+              <a:t>Network </a:t>
+            </a:r>
+            <a:br>
               <a:rPr lang="en-CH" dirty="0"/>
-              <a:t>?</a:t>
+            </a:br>
+            <a:r>
+              <a:rPr lang="en-CH" dirty="0"/>
+              <a:t>Architecture</a:t>
+            </a:r>
+            <a:br>
+              <a:rPr lang="en-CH" dirty="0"/>
+            </a:br>
+            <a:r>
+              <a:rPr lang="en-CH" dirty="0"/>
+              <a:t>Transformers</a:t>
+            </a:r>
+          </a:p>
+        </p:txBody>
+      </p:sp>
+      <p:sp>
+        <p:nvSpPr>
+          <p:cNvPr id="7" name="TextBox 6">
+            <a:extLst>
+              <a:ext uri="{FF2B5EF4-FFF2-40B4-BE49-F238E27FC236}">
+                <a16:creationId xmlns:a16="http://schemas.microsoft.com/office/drawing/2014/main" id="{AC382D56-0ED0-6B0E-8FC8-635117B2C041}"/>
+              </a:ext>
+            </a:extLst>
+          </p:cNvPr>
+          <p:cNvSpPr txBox="1"/>
+          <p:nvPr/>
+        </p:nvSpPr>
+        <p:spPr>
+          <a:xfrm>
+            <a:off x="0" y="6488668"/>
+            <a:ext cx="3560590" cy="369332"/>
+          </a:xfrm>
+          <a:prstGeom prst="rect">
+            <a:avLst/>
+          </a:prstGeom>
+          <a:noFill/>
+        </p:spPr>
+        <p:txBody>
+          <a:bodyPr wrap="none" rtlCol="0">
+            <a:spAutoFit/>
+          </a:bodyPr>
+          <a:lstStyle/>
+          <a:p>
+            <a:r>
+              <a:rPr lang="en-CH" i="1" dirty="0"/>
+              <a:t>Visualisation generated by Claude</a:t>
             </a:r>
           </a:p>
         </p:txBody>
@@ -4777,7 +7588,7 @@
     </p:spTree>
     <p:extLst>
       <p:ext uri="{BB962C8B-B14F-4D97-AF65-F5344CB8AC3E}">
-        <p14:creationId xmlns:p14="http://schemas.microsoft.com/office/powerpoint/2010/main" val="1607646033"/>
+        <p14:creationId xmlns:p14="http://schemas.microsoft.com/office/powerpoint/2010/main" val="1472725763"/>
       </p:ext>
     </p:extLst>
   </p:cSld>

</xml_diff>